<commit_message>
feat: implement NVD keyword-search fallback for components lacking CPEs and optimize NVD query performance by removing virtual match string fallbacks.
</commit_message>
<xml_diff>
--- a/SBOM_Analyser_HCLTech.pptx
+++ b/SBOM_Analyser_HCLTech.pptx
@@ -13,6 +13,8 @@
     <p:sldId id="261" r:id="rId7"/>
     <p:sldId id="262" r:id="rId8"/>
     <p:sldId id="263" r:id="rId9"/>
+    <p:sldId id="265" r:id="rId16"/>
+    <p:sldId id="266" r:id="rId17"/>
     <p:sldId id="264" r:id="rId10"/>
   </p:sldIdLst>
   <p:notesMasterIdLst>
@@ -2665,6 +2667,2944 @@
               <a:t>Presented by HCLTech  •  For all audiences</a:t>
             </a:r>
             <a:endParaRPr lang="en-US" sz="1200" dirty="0"/>
+          </a:p>
+        </p:txBody>
+      </p:sp>
+    </p:spTree>
+  </p:cSld>
+  <p:clrMapOvr>
+    <a:masterClrMapping/>
+  </p:clrMapOvr>
+</p:sld>
+</file>
+
+<file path=ppt/slides/slide10.xml><?xml version="1.0" encoding="utf-8"?>
+<p:sld xmlns:a="http://schemas.openxmlformats.org/drawingml/2006/main" xmlns:p="http://schemas.openxmlformats.org/presentationml/2006/main" xmlns:r="http://schemas.openxmlformats.org/officeDocument/2006/relationships">
+  <p:cSld>
+    <p:spTree>
+      <p:nvGrpSpPr>
+        <p:cNvPr id="1" name=""/>
+        <p:cNvGrpSpPr/>
+        <p:nvPr/>
+      </p:nvGrpSpPr>
+      <p:grpSpPr/>
+      <p:sp>
+        <p:nvSpPr>
+          <p:cNvPr id="2" name="Shape 0"/>
+          <p:cNvSpPr/>
+          <p:nvPr/>
+        </p:nvSpPr>
+        <p:spPr>
+          <a:xfrm>
+            <a:off x="0" y="0"/>
+            <a:ext cx="12161520" cy="109728"/>
+          </a:xfrm>
+          <a:prstGeom prst="rect">
+            <a:avLst/>
+          </a:prstGeom>
+          <a:solidFill>
+            <a:srgbClr val="00B5E2"/>
+          </a:solidFill>
+          <a:ln w="12700">
+            <a:solidFill>
+              <a:srgbClr val="00B5E2"/>
+            </a:solidFill>
+            <a:prstDash val="solid"/>
+          </a:ln>
+        </p:spPr>
+      </p:sp>
+      <p:sp>
+        <p:nvSpPr>
+          <p:cNvPr id="3" name="Text 1"/>
+          <p:cNvSpPr/>
+          <p:nvPr/>
+        </p:nvSpPr>
+        <p:spPr>
+          <a:xfrm>
+            <a:off x="457200" y="256032"/>
+            <a:ext cx="1828800" cy="457200"/>
+          </a:xfrm>
+          <a:prstGeom prst="rect">
+            <a:avLst/>
+          </a:prstGeom>
+          <a:noFill/>
+          <a:ln/>
+        </p:spPr>
+        <p:txBody>
+          <a:bodyPr wrap="square" lIns="0" tIns="0" rIns="0" bIns="0" rtlCol="0" anchor="ctr"/>
+          <a:lstStyle/>
+          <a:p>
+            <a:pPr indent="0" marL="0">
+              <a:buNone/>
+            </a:pPr>
+            <a:r>
+              <a:rPr lang="en-US" sz="1800" b="1" dirty="0">
+                <a:solidFill>
+                  <a:srgbClr val="004B87"/>
+                </a:solidFill>
+                <a:latin typeface="Calibri" pitchFamily="34" charset="0"/>
+                <a:ea typeface="Calibri" pitchFamily="34" charset="-122"/>
+                <a:cs typeface="Calibri" pitchFamily="34" charset="-120"/>
+              </a:rPr>
+              <a:t>HCL</a:t>
+            </a:r>
+            <a:pPr indent="0" marL="0">
+              <a:buNone/>
+            </a:pPr>
+            <a:r>
+              <a:rPr lang="en-US" sz="1800" b="1" dirty="0">
+                <a:solidFill>
+                  <a:srgbClr val="00B5E2"/>
+                </a:solidFill>
+                <a:latin typeface="Calibri" pitchFamily="34" charset="0"/>
+                <a:ea typeface="Calibri" pitchFamily="34" charset="-122"/>
+                <a:cs typeface="Calibri" pitchFamily="34" charset="-120"/>
+              </a:rPr>
+              <a:t>Tech</a:t>
+            </a:r>
+            <a:endParaRPr lang="en-US" sz="1800" dirty="0"/>
+          </a:p>
+        </p:txBody>
+      </p:sp>
+      <p:sp>
+        <p:nvSpPr>
+          <p:cNvPr id="4" name="Text 2"/>
+          <p:cNvSpPr/>
+          <p:nvPr/>
+        </p:nvSpPr>
+        <p:spPr>
+          <a:xfrm>
+            <a:off x="457200" y="777240"/>
+            <a:ext cx="10972800" cy="274320"/>
+          </a:xfrm>
+          <a:prstGeom prst="rect">
+            <a:avLst/>
+          </a:prstGeom>
+          <a:noFill/>
+          <a:ln/>
+        </p:spPr>
+        <p:txBody>
+          <a:bodyPr wrap="square" lIns="0" tIns="0" rIns="0" bIns="0" rtlCol="0" anchor="ctr"/>
+          <a:lstStyle/>
+          <a:p>
+            <a:pPr indent="0" marL="0">
+              <a:buNone/>
+            </a:pPr>
+            <a:r>
+              <a:rPr lang="en-US" sz="1100" b="1" spc="300" kern="0" dirty="0">
+                <a:solidFill>
+                  <a:srgbClr val="00B5E2"/>
+                </a:solidFill>
+                <a:latin typeface="Calibri" pitchFamily="34" charset="0"/>
+                <a:ea typeface="Calibri" pitchFamily="34" charset="-122"/>
+                <a:cs typeface="Calibri" pitchFamily="34" charset="-120"/>
+              </a:rPr>
+              <a:t>LATEST IMPLEMENTATION UPDATE</a:t>
+            </a:r>
+            <a:endParaRPr lang="en-US" sz="1100" dirty="0"/>
+          </a:p>
+        </p:txBody>
+      </p:sp>
+      <p:sp>
+        <p:nvSpPr>
+          <p:cNvPr id="5" name="Text 3"/>
+          <p:cNvSpPr/>
+          <p:nvPr/>
+        </p:nvSpPr>
+        <p:spPr>
+          <a:xfrm>
+            <a:off x="457200" y="1051560"/>
+            <a:ext cx="11247120" cy="822960"/>
+          </a:xfrm>
+          <a:prstGeom prst="rect">
+            <a:avLst/>
+          </a:prstGeom>
+          <a:noFill/>
+          <a:ln/>
+        </p:spPr>
+        <p:txBody>
+          <a:bodyPr wrap="square" lIns="0" tIns="0" rIns="0" bIns="0" rtlCol="0" anchor="ctr"/>
+          <a:lstStyle/>
+          <a:p>
+            <a:pPr indent="0" marL="0">
+              <a:buNone/>
+            </a:pPr>
+            <a:r>
+              <a:rPr lang="en-US" sz="3400" b="1" dirty="0">
+                <a:solidFill>
+                  <a:srgbClr val="001E3C"/>
+                </a:solidFill>
+                <a:latin typeface="Calibri" pitchFamily="34" charset="0"/>
+                <a:ea typeface="Calibri" pitchFamily="34" charset="-122"/>
+                <a:cs typeface="Calibri" pitchFamily="34" charset="-120"/>
+              </a:rPr>
+              <a:t>NVD keyword-search fallback</a:t>
+            </a:r>
+            <a:endParaRPr lang="en-US" sz="3400" dirty="0"/>
+          </a:p>
+        </p:txBody>
+      </p:sp>
+      <p:sp>
+        <p:nvSpPr>
+          <p:cNvPr id="6" name="Shape 4"/>
+          <p:cNvSpPr/>
+          <p:nvPr/>
+        </p:nvSpPr>
+        <p:spPr>
+          <a:xfrm>
+            <a:off x="457200" y="2057400"/>
+            <a:ext cx="3566160" cy="1805940"/>
+          </a:xfrm>
+          <a:prstGeom prst="rect">
+            <a:avLst/>
+          </a:prstGeom>
+          <a:solidFill>
+            <a:srgbClr val="FFFFFF"/>
+          </a:solidFill>
+          <a:ln w="12700">
+            <a:solidFill>
+              <a:srgbClr val="D8E1EC"/>
+            </a:solidFill>
+            <a:prstDash val="solid"/>
+          </a:ln>
+          <a:effectLst>
+            <a:outerShdw sx="100000" sy="100000" kx="0" ky="0" algn="bl" rotWithShape="0" blurRad="101600" dist="25400" dir="5400000">
+              <a:srgbClr val="000000">
+                <a:alpha val="7000"/>
+              </a:srgbClr>
+            </a:outerShdw>
+          </a:effectLst>
+        </p:spPr>
+      </p:sp>
+      <p:sp>
+        <p:nvSpPr>
+          <p:cNvPr id="7" name="Shape 5"/>
+          <p:cNvSpPr/>
+          <p:nvPr/>
+        </p:nvSpPr>
+        <p:spPr>
+          <a:xfrm>
+            <a:off x="457200" y="2057400"/>
+            <a:ext cx="3566160" cy="109728"/>
+          </a:xfrm>
+          <a:prstGeom prst="rect">
+            <a:avLst/>
+          </a:prstGeom>
+          <a:solidFill>
+            <a:srgbClr val="00B5E2"/>
+          </a:solidFill>
+          <a:ln w="12700">
+            <a:solidFill>
+              <a:srgbClr val="00B5E2"/>
+            </a:solidFill>
+            <a:prstDash val="solid"/>
+          </a:ln>
+        </p:spPr>
+      </p:sp>
+      <p:sp>
+        <p:nvSpPr>
+          <p:cNvPr id="8" name="Shape 6"/>
+          <p:cNvSpPr/>
+          <p:nvPr/>
+        </p:nvSpPr>
+        <p:spPr>
+          <a:xfrm>
+            <a:off x="731520" y="2377440"/>
+            <a:ext cx="685800" cy="685800"/>
+          </a:xfrm>
+          <a:prstGeom prst="ellipse">
+            <a:avLst/>
+          </a:prstGeom>
+          <a:solidFill>
+            <a:srgbClr val="004B87"/>
+          </a:solidFill>
+          <a:ln w="12700">
+            <a:solidFill>
+              <a:srgbClr val="004B87"/>
+            </a:solidFill>
+            <a:prstDash val="solid"/>
+          </a:ln>
+        </p:spPr>
+      </p:sp>
+      <p:sp>
+        <p:nvSpPr>
+          <p:cNvPr id="9" name="Text 7"/>
+          <p:cNvSpPr/>
+          <p:nvPr/>
+        </p:nvSpPr>
+        <p:spPr>
+          <a:xfrm>
+            <a:off x="731520" y="2377440"/>
+            <a:ext cx="685800" cy="685800"/>
+          </a:xfrm>
+          <a:prstGeom prst="rect">
+            <a:avLst/>
+          </a:prstGeom>
+          <a:noFill/>
+          <a:ln/>
+        </p:spPr>
+        <p:txBody>
+          <a:bodyPr wrap="square" lIns="0" tIns="0" rIns="0" bIns="0" rtlCol="0" anchor="ctr"/>
+          <a:lstStyle/>
+          <a:p>
+            <a:pPr algn="ctr" indent="0" marL="0">
+              <a:buNone/>
+            </a:pPr>
+            <a:r>
+              <a:rPr lang="en-US" sz="1400" b="1" dirty="0">
+                <a:solidFill>
+                  <a:srgbClr val="FFFFFF"/>
+                </a:solidFill>
+                <a:latin typeface="Calibri" pitchFamily="34" charset="0"/>
+                <a:ea typeface="Calibri" pitchFamily="34" charset="-122"/>
+                <a:cs typeface="Calibri" pitchFamily="34" charset="-120"/>
+              </a:rPr>
+              <a:t>01</a:t>
+            </a:r>
+            <a:endParaRPr lang="en-US" sz="1400" dirty="0"/>
+          </a:p>
+        </p:txBody>
+      </p:sp>
+      <p:sp>
+        <p:nvSpPr>
+          <p:cNvPr id="10" name="Text 8"/>
+          <p:cNvSpPr/>
+          <p:nvPr/>
+        </p:nvSpPr>
+        <p:spPr>
+          <a:xfrm>
+            <a:off x="1554480" y="2423160"/>
+            <a:ext cx="2331720" cy="594360"/>
+          </a:xfrm>
+          <a:prstGeom prst="rect">
+            <a:avLst/>
+          </a:prstGeom>
+          <a:noFill/>
+          <a:ln/>
+        </p:spPr>
+        <p:txBody>
+          <a:bodyPr wrap="square" lIns="0" tIns="0" rIns="0" bIns="0" rtlCol="0" anchor="ctr"/>
+          <a:lstStyle/>
+          <a:p>
+            <a:pPr indent="0" marL="0">
+              <a:buNone/>
+            </a:pPr>
+            <a:r>
+              <a:rPr lang="en-US" sz="1700" b="1" dirty="0">
+                <a:solidFill>
+                  <a:srgbClr val="001E3C"/>
+                </a:solidFill>
+                <a:latin typeface="Calibri" pitchFamily="34" charset="0"/>
+                <a:ea typeface="Calibri" pitchFamily="34" charset="-122"/>
+                <a:cs typeface="Calibri" pitchFamily="34" charset="-120"/>
+              </a:rPr>
+              <a:t>The gap</a:t>
+            </a:r>
+            <a:endParaRPr lang="en-US" sz="1700" dirty="0"/>
+          </a:p>
+        </p:txBody>
+      </p:sp>
+      <p:sp>
+        <p:nvSpPr>
+          <p:cNvPr id="11" name="Text 9"/>
+          <p:cNvSpPr/>
+          <p:nvPr/>
+        </p:nvSpPr>
+        <p:spPr>
+          <a:xfrm>
+            <a:off x="731520" y="3200400"/>
+            <a:ext cx="3017520" cy="525780"/>
+          </a:xfrm>
+          <a:prstGeom prst="rect">
+            <a:avLst/>
+          </a:prstGeom>
+          <a:noFill/>
+          <a:ln/>
+        </p:spPr>
+        <p:txBody>
+          <a:bodyPr wrap="square" rtlCol="0" anchor="ctr"/>
+          <a:lstStyle/>
+          <a:p>
+            <a:pPr indent="0" marL="0">
+              <a:buNone/>
+            </a:pPr>
+            <a:r>
+              <a:rPr lang="en-US" sz="1300" dirty="0">
+                <a:solidFill>
+                  <a:srgbClr val="1E293B"/>
+                </a:solidFill>
+                <a:latin typeface="Calibri" pitchFamily="34" charset="0"/>
+                <a:ea typeface="Calibri" pitchFamily="34" charset="-122"/>
+                <a:cs typeface="Calibri" pitchFamily="34" charset="-120"/>
+              </a:rPr>
+              <a:t>Minimal SPDX and PURL-less SBOMs returned zero NVD findings because the engine required a CPE to query.</a:t>
+            </a:r>
+            <a:endParaRPr lang="en-US" sz="1300" dirty="0"/>
+          </a:p>
+        </p:txBody>
+      </p:sp>
+      <p:sp>
+        <p:nvSpPr>
+          <p:cNvPr id="12" name="Shape 10"/>
+          <p:cNvSpPr/>
+          <p:nvPr/>
+        </p:nvSpPr>
+        <p:spPr>
+          <a:xfrm>
+            <a:off x="4297680" y="2057400"/>
+            <a:ext cx="3566160" cy="1805940"/>
+          </a:xfrm>
+          <a:prstGeom prst="rect">
+            <a:avLst/>
+          </a:prstGeom>
+          <a:solidFill>
+            <a:srgbClr val="FFFFFF"/>
+          </a:solidFill>
+          <a:ln w="12700">
+            <a:solidFill>
+              <a:srgbClr val="D8E1EC"/>
+            </a:solidFill>
+            <a:prstDash val="solid"/>
+          </a:ln>
+          <a:effectLst>
+            <a:outerShdw sx="100000" sy="100000" kx="0" ky="0" algn="bl" rotWithShape="0" blurRad="101600" dist="25400" dir="5400000">
+              <a:srgbClr val="000000">
+                <a:alpha val="7000"/>
+              </a:srgbClr>
+            </a:outerShdw>
+          </a:effectLst>
+        </p:spPr>
+      </p:sp>
+      <p:sp>
+        <p:nvSpPr>
+          <p:cNvPr id="13" name="Shape 11"/>
+          <p:cNvSpPr/>
+          <p:nvPr/>
+        </p:nvSpPr>
+        <p:spPr>
+          <a:xfrm>
+            <a:off x="4297680" y="2057400"/>
+            <a:ext cx="3566160" cy="109728"/>
+          </a:xfrm>
+          <a:prstGeom prst="rect">
+            <a:avLst/>
+          </a:prstGeom>
+          <a:solidFill>
+            <a:srgbClr val="00B5E2"/>
+          </a:solidFill>
+          <a:ln w="12700">
+            <a:solidFill>
+              <a:srgbClr val="00B5E2"/>
+            </a:solidFill>
+            <a:prstDash val="solid"/>
+          </a:ln>
+        </p:spPr>
+      </p:sp>
+      <p:sp>
+        <p:nvSpPr>
+          <p:cNvPr id="14" name="Shape 12"/>
+          <p:cNvSpPr/>
+          <p:nvPr/>
+        </p:nvSpPr>
+        <p:spPr>
+          <a:xfrm>
+            <a:off x="4572000" y="2377440"/>
+            <a:ext cx="685800" cy="685800"/>
+          </a:xfrm>
+          <a:prstGeom prst="ellipse">
+            <a:avLst/>
+          </a:prstGeom>
+          <a:solidFill>
+            <a:srgbClr val="004B87"/>
+          </a:solidFill>
+          <a:ln w="12700">
+            <a:solidFill>
+              <a:srgbClr val="004B87"/>
+            </a:solidFill>
+            <a:prstDash val="solid"/>
+          </a:ln>
+        </p:spPr>
+      </p:sp>
+      <p:sp>
+        <p:nvSpPr>
+          <p:cNvPr id="15" name="Text 13"/>
+          <p:cNvSpPr/>
+          <p:nvPr/>
+        </p:nvSpPr>
+        <p:spPr>
+          <a:xfrm>
+            <a:off x="4572000" y="2377440"/>
+            <a:ext cx="685800" cy="685800"/>
+          </a:xfrm>
+          <a:prstGeom prst="rect">
+            <a:avLst/>
+          </a:prstGeom>
+          <a:noFill/>
+          <a:ln/>
+        </p:spPr>
+        <p:txBody>
+          <a:bodyPr wrap="square" lIns="0" tIns="0" rIns="0" bIns="0" rtlCol="0" anchor="ctr"/>
+          <a:lstStyle/>
+          <a:p>
+            <a:pPr algn="ctr" indent="0" marL="0">
+              <a:buNone/>
+            </a:pPr>
+            <a:r>
+              <a:rPr lang="en-US" sz="1400" b="1" dirty="0">
+                <a:solidFill>
+                  <a:srgbClr val="FFFFFF"/>
+                </a:solidFill>
+                <a:latin typeface="Calibri" pitchFamily="34" charset="0"/>
+                <a:ea typeface="Calibri" pitchFamily="34" charset="-122"/>
+                <a:cs typeface="Calibri" pitchFamily="34" charset="-120"/>
+              </a:rPr>
+              <a:t>02</a:t>
+            </a:r>
+            <a:endParaRPr lang="en-US" sz="1400" dirty="0"/>
+          </a:p>
+        </p:txBody>
+      </p:sp>
+      <p:sp>
+        <p:nvSpPr>
+          <p:cNvPr id="16" name="Text 14"/>
+          <p:cNvSpPr/>
+          <p:nvPr/>
+        </p:nvSpPr>
+        <p:spPr>
+          <a:xfrm>
+            <a:off x="5394960" y="2423160"/>
+            <a:ext cx="2331720" cy="594360"/>
+          </a:xfrm>
+          <a:prstGeom prst="rect">
+            <a:avLst/>
+          </a:prstGeom>
+          <a:noFill/>
+          <a:ln/>
+        </p:spPr>
+        <p:txBody>
+          <a:bodyPr wrap="square" lIns="0" tIns="0" rIns="0" bIns="0" rtlCol="0" anchor="ctr"/>
+          <a:lstStyle/>
+          <a:p>
+            <a:pPr indent="0" marL="0">
+              <a:buNone/>
+            </a:pPr>
+            <a:r>
+              <a:rPr lang="en-US" sz="1700" b="1" dirty="0">
+                <a:solidFill>
+                  <a:srgbClr val="001E3C"/>
+                </a:solidFill>
+                <a:latin typeface="Calibri" pitchFamily="34" charset="0"/>
+                <a:ea typeface="Calibri" pitchFamily="34" charset="-122"/>
+                <a:cs typeface="Calibri" pitchFamily="34" charset="-120"/>
+              </a:rPr>
+              <a:t>Root cause</a:t>
+            </a:r>
+            <a:endParaRPr lang="en-US" sz="1700" dirty="0"/>
+          </a:p>
+        </p:txBody>
+      </p:sp>
+      <p:sp>
+        <p:nvSpPr>
+          <p:cNvPr id="17" name="Text 15"/>
+          <p:cNvSpPr/>
+          <p:nvPr/>
+        </p:nvSpPr>
+        <p:spPr>
+          <a:xfrm>
+            <a:off x="4572000" y="3200400"/>
+            <a:ext cx="3017520" cy="525780"/>
+          </a:xfrm>
+          <a:prstGeom prst="rect">
+            <a:avLst/>
+          </a:prstGeom>
+          <a:noFill/>
+          <a:ln/>
+        </p:spPr>
+        <p:txBody>
+          <a:bodyPr wrap="square" rtlCol="0" anchor="ctr"/>
+          <a:lstStyle/>
+          <a:p>
+            <a:pPr indent="0" marL="0">
+              <a:buNone/>
+            </a:pPr>
+            <a:r>
+              <a:rPr lang="en-US" sz="1300" dirty="0">
+                <a:solidFill>
+                  <a:srgbClr val="1E293B"/>
+                </a:solidFill>
+                <a:latin typeface="Calibri" pitchFamily="34" charset="0"/>
+                <a:ea typeface="Calibri" pitchFamily="34" charset="-122"/>
+                <a:cs typeface="Calibri" pitchFamily="34" charset="-120"/>
+              </a:rPr>
+              <a:t>Components without a CPE (or a PURL that maps to one) caused NVD to be skipped entirely across three code paths.</a:t>
+            </a:r>
+            <a:endParaRPr lang="en-US" sz="1300" dirty="0"/>
+          </a:p>
+        </p:txBody>
+      </p:sp>
+      <p:sp>
+        <p:nvSpPr>
+          <p:cNvPr id="18" name="Shape 16"/>
+          <p:cNvSpPr/>
+          <p:nvPr/>
+        </p:nvSpPr>
+        <p:spPr>
+          <a:xfrm>
+            <a:off x="8138160" y="2057400"/>
+            <a:ext cx="3566160" cy="1805940"/>
+          </a:xfrm>
+          <a:prstGeom prst="rect">
+            <a:avLst/>
+          </a:prstGeom>
+          <a:solidFill>
+            <a:srgbClr val="FFFFFF"/>
+          </a:solidFill>
+          <a:ln w="12700">
+            <a:solidFill>
+              <a:srgbClr val="D8E1EC"/>
+            </a:solidFill>
+            <a:prstDash val="solid"/>
+          </a:ln>
+          <a:effectLst>
+            <a:outerShdw sx="100000" sy="100000" kx="0" ky="0" algn="bl" rotWithShape="0" blurRad="101600" dist="25400" dir="5400000">
+              <a:srgbClr val="000000">
+                <a:alpha val="7000"/>
+              </a:srgbClr>
+            </a:outerShdw>
+          </a:effectLst>
+        </p:spPr>
+      </p:sp>
+      <p:sp>
+        <p:nvSpPr>
+          <p:cNvPr id="19" name="Shape 17"/>
+          <p:cNvSpPr/>
+          <p:nvPr/>
+        </p:nvSpPr>
+        <p:spPr>
+          <a:xfrm>
+            <a:off x="8138160" y="2057400"/>
+            <a:ext cx="3566160" cy="109728"/>
+          </a:xfrm>
+          <a:prstGeom prst="rect">
+            <a:avLst/>
+          </a:prstGeom>
+          <a:solidFill>
+            <a:srgbClr val="00B5E2"/>
+          </a:solidFill>
+          <a:ln w="12700">
+            <a:solidFill>
+              <a:srgbClr val="00B5E2"/>
+            </a:solidFill>
+            <a:prstDash val="solid"/>
+          </a:ln>
+        </p:spPr>
+      </p:sp>
+      <p:sp>
+        <p:nvSpPr>
+          <p:cNvPr id="20" name="Shape 18"/>
+          <p:cNvSpPr/>
+          <p:nvPr/>
+        </p:nvSpPr>
+        <p:spPr>
+          <a:xfrm>
+            <a:off x="8412480" y="2377440"/>
+            <a:ext cx="685800" cy="685800"/>
+          </a:xfrm>
+          <a:prstGeom prst="ellipse">
+            <a:avLst/>
+          </a:prstGeom>
+          <a:solidFill>
+            <a:srgbClr val="004B87"/>
+          </a:solidFill>
+          <a:ln w="12700">
+            <a:solidFill>
+              <a:srgbClr val="004B87"/>
+            </a:solidFill>
+            <a:prstDash val="solid"/>
+          </a:ln>
+        </p:spPr>
+      </p:sp>
+      <p:sp>
+        <p:nvSpPr>
+          <p:cNvPr id="21" name="Text 19"/>
+          <p:cNvSpPr/>
+          <p:nvPr/>
+        </p:nvSpPr>
+        <p:spPr>
+          <a:xfrm>
+            <a:off x="8412480" y="2377440"/>
+            <a:ext cx="685800" cy="685800"/>
+          </a:xfrm>
+          <a:prstGeom prst="rect">
+            <a:avLst/>
+          </a:prstGeom>
+          <a:noFill/>
+          <a:ln/>
+        </p:spPr>
+        <p:txBody>
+          <a:bodyPr wrap="square" lIns="0" tIns="0" rIns="0" bIns="0" rtlCol="0" anchor="ctr"/>
+          <a:lstStyle/>
+          <a:p>
+            <a:pPr algn="ctr" indent="0" marL="0">
+              <a:buNone/>
+            </a:pPr>
+            <a:r>
+              <a:rPr lang="en-US" sz="1400" b="1" dirty="0">
+                <a:solidFill>
+                  <a:srgbClr val="FFFFFF"/>
+                </a:solidFill>
+                <a:latin typeface="Calibri" pitchFamily="34" charset="0"/>
+                <a:ea typeface="Calibri" pitchFamily="34" charset="-122"/>
+                <a:cs typeface="Calibri" pitchFamily="34" charset="-120"/>
+              </a:rPr>
+              <a:t>03</a:t>
+            </a:r>
+            <a:endParaRPr lang="en-US" sz="1400" dirty="0"/>
+          </a:p>
+        </p:txBody>
+      </p:sp>
+      <p:sp>
+        <p:nvSpPr>
+          <p:cNvPr id="22" name="Text 20"/>
+          <p:cNvSpPr/>
+          <p:nvPr/>
+        </p:nvSpPr>
+        <p:spPr>
+          <a:xfrm>
+            <a:off x="9235440" y="2423160"/>
+            <a:ext cx="2331720" cy="594360"/>
+          </a:xfrm>
+          <a:prstGeom prst="rect">
+            <a:avLst/>
+          </a:prstGeom>
+          <a:noFill/>
+          <a:ln/>
+        </p:spPr>
+        <p:txBody>
+          <a:bodyPr wrap="square" lIns="0" tIns="0" rIns="0" bIns="0" rtlCol="0" anchor="ctr"/>
+          <a:lstStyle/>
+          <a:p>
+            <a:pPr indent="0" marL="0">
+              <a:buNone/>
+            </a:pPr>
+            <a:r>
+              <a:rPr lang="en-US" sz="1700" b="1" dirty="0">
+                <a:solidFill>
+                  <a:srgbClr val="001E3C"/>
+                </a:solidFill>
+                <a:latin typeface="Calibri" pitchFamily="34" charset="0"/>
+                <a:ea typeface="Calibri" pitchFamily="34" charset="-122"/>
+                <a:cs typeface="Calibri" pitchFamily="34" charset="-120"/>
+              </a:rPr>
+              <a:t>The fix</a:t>
+            </a:r>
+            <a:endParaRPr lang="en-US" sz="1700" dirty="0"/>
+          </a:p>
+        </p:txBody>
+      </p:sp>
+      <p:sp>
+        <p:nvSpPr>
+          <p:cNvPr id="23" name="Text 21"/>
+          <p:cNvSpPr/>
+          <p:nvPr/>
+        </p:nvSpPr>
+        <p:spPr>
+          <a:xfrm>
+            <a:off x="8412480" y="3200400"/>
+            <a:ext cx="3017520" cy="525780"/>
+          </a:xfrm>
+          <a:prstGeom prst="rect">
+            <a:avLst/>
+          </a:prstGeom>
+          <a:noFill/>
+          <a:ln/>
+        </p:spPr>
+        <p:txBody>
+          <a:bodyPr wrap="square" rtlCol="0" anchor="ctr"/>
+          <a:lstStyle/>
+          <a:p>
+            <a:pPr indent="0" marL="0">
+              <a:buNone/>
+            </a:pPr>
+            <a:r>
+              <a:rPr lang="en-US" sz="1300" dirty="0">
+                <a:solidFill>
+                  <a:srgbClr val="1E293B"/>
+                </a:solidFill>
+                <a:latin typeface="Calibri" pitchFamily="34" charset="0"/>
+                <a:ea typeface="Calibri" pitchFamily="34" charset="-122"/>
+                <a:cs typeface="Calibri" pitchFamily="34" charset="-120"/>
+              </a:rPr>
+              <a:t>Added nvd_query_by_keyword; CPE-less components now fall through to NVD's keywordSearch — mirroring the standalone script.</a:t>
+            </a:r>
+            <a:endParaRPr lang="en-US" sz="1300" dirty="0"/>
+          </a:p>
+        </p:txBody>
+      </p:sp>
+      <p:sp>
+        <p:nvSpPr>
+          <p:cNvPr id="24" name="Shape 22"/>
+          <p:cNvSpPr/>
+          <p:nvPr/>
+        </p:nvSpPr>
+        <p:spPr>
+          <a:xfrm>
+            <a:off x="457200" y="4137660"/>
+            <a:ext cx="3566160" cy="1805940"/>
+          </a:xfrm>
+          <a:prstGeom prst="rect">
+            <a:avLst/>
+          </a:prstGeom>
+          <a:solidFill>
+            <a:srgbClr val="FFFFFF"/>
+          </a:solidFill>
+          <a:ln w="12700">
+            <a:solidFill>
+              <a:srgbClr val="D8E1EC"/>
+            </a:solidFill>
+            <a:prstDash val="solid"/>
+          </a:ln>
+          <a:effectLst>
+            <a:outerShdw sx="100000" sy="100000" kx="0" ky="0" algn="bl" rotWithShape="0" blurRad="101600" dist="25400" dir="5400000">
+              <a:srgbClr val="000000">
+                <a:alpha val="7000"/>
+              </a:srgbClr>
+            </a:outerShdw>
+          </a:effectLst>
+        </p:spPr>
+      </p:sp>
+      <p:sp>
+        <p:nvSpPr>
+          <p:cNvPr id="25" name="Shape 23"/>
+          <p:cNvSpPr/>
+          <p:nvPr/>
+        </p:nvSpPr>
+        <p:spPr>
+          <a:xfrm>
+            <a:off x="457200" y="4137660"/>
+            <a:ext cx="3566160" cy="109728"/>
+          </a:xfrm>
+          <a:prstGeom prst="rect">
+            <a:avLst/>
+          </a:prstGeom>
+          <a:solidFill>
+            <a:srgbClr val="00B5E2"/>
+          </a:solidFill>
+          <a:ln w="12700">
+            <a:solidFill>
+              <a:srgbClr val="00B5E2"/>
+            </a:solidFill>
+            <a:prstDash val="solid"/>
+          </a:ln>
+        </p:spPr>
+      </p:sp>
+      <p:sp>
+        <p:nvSpPr>
+          <p:cNvPr id="26" name="Shape 24"/>
+          <p:cNvSpPr/>
+          <p:nvPr/>
+        </p:nvSpPr>
+        <p:spPr>
+          <a:xfrm>
+            <a:off x="731520" y="4457700"/>
+            <a:ext cx="685800" cy="685800"/>
+          </a:xfrm>
+          <a:prstGeom prst="ellipse">
+            <a:avLst/>
+          </a:prstGeom>
+          <a:solidFill>
+            <a:srgbClr val="004B87"/>
+          </a:solidFill>
+          <a:ln w="12700">
+            <a:solidFill>
+              <a:srgbClr val="004B87"/>
+            </a:solidFill>
+            <a:prstDash val="solid"/>
+          </a:ln>
+        </p:spPr>
+      </p:sp>
+      <p:sp>
+        <p:nvSpPr>
+          <p:cNvPr id="27" name="Text 25"/>
+          <p:cNvSpPr/>
+          <p:nvPr/>
+        </p:nvSpPr>
+        <p:spPr>
+          <a:xfrm>
+            <a:off x="731520" y="4457700"/>
+            <a:ext cx="685800" cy="685800"/>
+          </a:xfrm>
+          <a:prstGeom prst="rect">
+            <a:avLst/>
+          </a:prstGeom>
+          <a:noFill/>
+          <a:ln/>
+        </p:spPr>
+        <p:txBody>
+          <a:bodyPr wrap="square" lIns="0" tIns="0" rIns="0" bIns="0" rtlCol="0" anchor="ctr"/>
+          <a:lstStyle/>
+          <a:p>
+            <a:pPr algn="ctr" indent="0" marL="0">
+              <a:buNone/>
+            </a:pPr>
+            <a:r>
+              <a:rPr lang="en-US" sz="1400" b="1" dirty="0">
+                <a:solidFill>
+                  <a:srgbClr val="FFFFFF"/>
+                </a:solidFill>
+                <a:latin typeface="Calibri" pitchFamily="34" charset="0"/>
+                <a:ea typeface="Calibri" pitchFamily="34" charset="-122"/>
+                <a:cs typeface="Calibri" pitchFamily="34" charset="-120"/>
+              </a:rPr>
+              <a:t>04</a:t>
+            </a:r>
+            <a:endParaRPr lang="en-US" sz="1400" dirty="0"/>
+          </a:p>
+        </p:txBody>
+      </p:sp>
+      <p:sp>
+        <p:nvSpPr>
+          <p:cNvPr id="28" name="Text 26"/>
+          <p:cNvSpPr/>
+          <p:nvPr/>
+        </p:nvSpPr>
+        <p:spPr>
+          <a:xfrm>
+            <a:off x="1554480" y="4503420"/>
+            <a:ext cx="2331720" cy="594360"/>
+          </a:xfrm>
+          <a:prstGeom prst="rect">
+            <a:avLst/>
+          </a:prstGeom>
+          <a:noFill/>
+          <a:ln/>
+        </p:spPr>
+        <p:txBody>
+          <a:bodyPr wrap="square" lIns="0" tIns="0" rIns="0" bIns="0" rtlCol="0" anchor="ctr"/>
+          <a:lstStyle/>
+          <a:p>
+            <a:pPr indent="0" marL="0">
+              <a:buNone/>
+            </a:pPr>
+            <a:r>
+              <a:rPr lang="en-US" sz="1700" b="1" dirty="0">
+                <a:solidFill>
+                  <a:srgbClr val="001E3C"/>
+                </a:solidFill>
+                <a:latin typeface="Calibri" pitchFamily="34" charset="0"/>
+                <a:ea typeface="Calibri" pitchFamily="34" charset="-122"/>
+                <a:cs typeface="Calibri" pitchFamily="34" charset="-120"/>
+              </a:rPr>
+              <a:t>Two-phase fan-out</a:t>
+            </a:r>
+            <a:endParaRPr lang="en-US" sz="1700" dirty="0"/>
+          </a:p>
+        </p:txBody>
+      </p:sp>
+      <p:sp>
+        <p:nvSpPr>
+          <p:cNvPr id="29" name="Text 27"/>
+          <p:cNvSpPr/>
+          <p:nvPr/>
+        </p:nvSpPr>
+        <p:spPr>
+          <a:xfrm>
+            <a:off x="731520" y="5280660"/>
+            <a:ext cx="3017520" cy="525780"/>
+          </a:xfrm>
+          <a:prstGeom prst="rect">
+            <a:avLst/>
+          </a:prstGeom>
+          <a:noFill/>
+          <a:ln/>
+        </p:spPr>
+        <p:txBody>
+          <a:bodyPr wrap="square" rtlCol="0" anchor="ctr"/>
+          <a:lstStyle/>
+          <a:p>
+            <a:pPr indent="0" marL="0">
+              <a:buNone/>
+            </a:pPr>
+            <a:r>
+              <a:rPr lang="en-US" sz="1300" dirty="0">
+                <a:solidFill>
+                  <a:srgbClr val="1E293B"/>
+                </a:solidFill>
+                <a:latin typeface="Calibri" pitchFamily="34" charset="0"/>
+                <a:ea typeface="Calibri" pitchFamily="34" charset="-122"/>
+                <a:cs typeface="Calibri" pitchFamily="34" charset="-120"/>
+              </a:rPr>
+              <a:t>CPE components use cpeName + virtualMatchString; CPE-less components use keywordSearch. Both share the concurrency semaphore.</a:t>
+            </a:r>
+            <a:endParaRPr lang="en-US" sz="1300" dirty="0"/>
+          </a:p>
+        </p:txBody>
+      </p:sp>
+      <p:sp>
+        <p:nvSpPr>
+          <p:cNvPr id="30" name="Shape 28"/>
+          <p:cNvSpPr/>
+          <p:nvPr/>
+        </p:nvSpPr>
+        <p:spPr>
+          <a:xfrm>
+            <a:off x="4297680" y="4137660"/>
+            <a:ext cx="3566160" cy="1805940"/>
+          </a:xfrm>
+          <a:prstGeom prst="rect">
+            <a:avLst/>
+          </a:prstGeom>
+          <a:solidFill>
+            <a:srgbClr val="FFFFFF"/>
+          </a:solidFill>
+          <a:ln w="12700">
+            <a:solidFill>
+              <a:srgbClr val="D8E1EC"/>
+            </a:solidFill>
+            <a:prstDash val="solid"/>
+          </a:ln>
+          <a:effectLst>
+            <a:outerShdw sx="100000" sy="100000" kx="0" ky="0" algn="bl" rotWithShape="0" blurRad="101600" dist="25400" dir="5400000">
+              <a:srgbClr val="000000">
+                <a:alpha val="7000"/>
+              </a:srgbClr>
+            </a:outerShdw>
+          </a:effectLst>
+        </p:spPr>
+      </p:sp>
+      <p:sp>
+        <p:nvSpPr>
+          <p:cNvPr id="31" name="Shape 29"/>
+          <p:cNvSpPr/>
+          <p:nvPr/>
+        </p:nvSpPr>
+        <p:spPr>
+          <a:xfrm>
+            <a:off x="4297680" y="4137660"/>
+            <a:ext cx="3566160" cy="109728"/>
+          </a:xfrm>
+          <a:prstGeom prst="rect">
+            <a:avLst/>
+          </a:prstGeom>
+          <a:solidFill>
+            <a:srgbClr val="00B5E2"/>
+          </a:solidFill>
+          <a:ln w="12700">
+            <a:solidFill>
+              <a:srgbClr val="00B5E2"/>
+            </a:solidFill>
+            <a:prstDash val="solid"/>
+          </a:ln>
+        </p:spPr>
+      </p:sp>
+      <p:sp>
+        <p:nvSpPr>
+          <p:cNvPr id="32" name="Shape 30"/>
+          <p:cNvSpPr/>
+          <p:nvPr/>
+        </p:nvSpPr>
+        <p:spPr>
+          <a:xfrm>
+            <a:off x="4572000" y="4457700"/>
+            <a:ext cx="685800" cy="685800"/>
+          </a:xfrm>
+          <a:prstGeom prst="ellipse">
+            <a:avLst/>
+          </a:prstGeom>
+          <a:solidFill>
+            <a:srgbClr val="004B87"/>
+          </a:solidFill>
+          <a:ln w="12700">
+            <a:solidFill>
+              <a:srgbClr val="004B87"/>
+            </a:solidFill>
+            <a:prstDash val="solid"/>
+          </a:ln>
+        </p:spPr>
+      </p:sp>
+      <p:sp>
+        <p:nvSpPr>
+          <p:cNvPr id="33" name="Text 31"/>
+          <p:cNvSpPr/>
+          <p:nvPr/>
+        </p:nvSpPr>
+        <p:spPr>
+          <a:xfrm>
+            <a:off x="4572000" y="4457700"/>
+            <a:ext cx="685800" cy="685800"/>
+          </a:xfrm>
+          <a:prstGeom prst="rect">
+            <a:avLst/>
+          </a:prstGeom>
+          <a:noFill/>
+          <a:ln/>
+        </p:spPr>
+        <p:txBody>
+          <a:bodyPr wrap="square" lIns="0" tIns="0" rIns="0" bIns="0" rtlCol="0" anchor="ctr"/>
+          <a:lstStyle/>
+          <a:p>
+            <a:pPr algn="ctr" indent="0" marL="0">
+              <a:buNone/>
+            </a:pPr>
+            <a:r>
+              <a:rPr lang="en-US" sz="1400" b="1" dirty="0">
+                <a:solidFill>
+                  <a:srgbClr val="FFFFFF"/>
+                </a:solidFill>
+                <a:latin typeface="Calibri" pitchFamily="34" charset="0"/>
+                <a:ea typeface="Calibri" pitchFamily="34" charset="-122"/>
+                <a:cs typeface="Calibri" pitchFamily="34" charset="-120"/>
+              </a:rPr>
+              <a:t>05</a:t>
+            </a:r>
+            <a:endParaRPr lang="en-US" sz="1400" dirty="0"/>
+          </a:p>
+        </p:txBody>
+      </p:sp>
+      <p:sp>
+        <p:nvSpPr>
+          <p:cNvPr id="34" name="Text 32"/>
+          <p:cNvSpPr/>
+          <p:nvPr/>
+        </p:nvSpPr>
+        <p:spPr>
+          <a:xfrm>
+            <a:off x="5394960" y="4503420"/>
+            <a:ext cx="2331720" cy="594360"/>
+          </a:xfrm>
+          <a:prstGeom prst="rect">
+            <a:avLst/>
+          </a:prstGeom>
+          <a:noFill/>
+          <a:ln/>
+        </p:spPr>
+        <p:txBody>
+          <a:bodyPr wrap="square" lIns="0" tIns="0" rIns="0" bIns="0" rtlCol="0" anchor="ctr"/>
+          <a:lstStyle/>
+          <a:p>
+            <a:pPr indent="0" marL="0">
+              <a:buNone/>
+            </a:pPr>
+            <a:r>
+              <a:rPr lang="en-US" sz="1700" b="1" dirty="0">
+                <a:solidFill>
+                  <a:srgbClr val="001E3C"/>
+                </a:solidFill>
+                <a:latin typeface="Calibri" pitchFamily="34" charset="0"/>
+                <a:ea typeface="Calibri" pitchFamily="34" charset="-122"/>
+                <a:cs typeface="Calibri" pitchFamily="34" charset="-120"/>
+              </a:rPr>
+              <a:t>Verified</a:t>
+            </a:r>
+            <a:endParaRPr lang="en-US" sz="1700" dirty="0"/>
+          </a:p>
+        </p:txBody>
+      </p:sp>
+      <p:sp>
+        <p:nvSpPr>
+          <p:cNvPr id="35" name="Text 33"/>
+          <p:cNvSpPr/>
+          <p:nvPr/>
+        </p:nvSpPr>
+        <p:spPr>
+          <a:xfrm>
+            <a:off x="4572000" y="5280660"/>
+            <a:ext cx="3017520" cy="525780"/>
+          </a:xfrm>
+          <a:prstGeom prst="rect">
+            <a:avLst/>
+          </a:prstGeom>
+          <a:noFill/>
+          <a:ln/>
+        </p:spPr>
+        <p:txBody>
+          <a:bodyPr wrap="square" rtlCol="0" anchor="ctr"/>
+          <a:lstStyle/>
+          <a:p>
+            <a:pPr indent="0" marL="0">
+              <a:buNone/>
+            </a:pPr>
+            <a:r>
+              <a:rPr lang="en-US" sz="1300" dirty="0">
+                <a:solidFill>
+                  <a:srgbClr val="1E293B"/>
+                </a:solidFill>
+                <a:latin typeface="Calibri" pitchFamily="34" charset="0"/>
+                <a:ea typeface="Calibri" pitchFamily="34" charset="-122"/>
+                <a:cs typeface="Calibri" pitchFamily="34" charset="-120"/>
+              </a:rPr>
+              <a:t>12 of 12 existing NVD + adapter tests pass. Mocked SBOM: 0 findings before → N findings after, one per CPE-less component.</a:t>
+            </a:r>
+            <a:endParaRPr lang="en-US" sz="1300" dirty="0"/>
+          </a:p>
+        </p:txBody>
+      </p:sp>
+      <p:sp>
+        <p:nvSpPr>
+          <p:cNvPr id="36" name="Shape 34"/>
+          <p:cNvSpPr/>
+          <p:nvPr/>
+        </p:nvSpPr>
+        <p:spPr>
+          <a:xfrm>
+            <a:off x="8138160" y="4137660"/>
+            <a:ext cx="3566160" cy="1805940"/>
+          </a:xfrm>
+          <a:prstGeom prst="rect">
+            <a:avLst/>
+          </a:prstGeom>
+          <a:solidFill>
+            <a:srgbClr val="FFFFFF"/>
+          </a:solidFill>
+          <a:ln w="12700">
+            <a:solidFill>
+              <a:srgbClr val="D8E1EC"/>
+            </a:solidFill>
+            <a:prstDash val="solid"/>
+          </a:ln>
+          <a:effectLst>
+            <a:outerShdw sx="100000" sy="100000" kx="0" ky="0" algn="bl" rotWithShape="0" blurRad="101600" dist="25400" dir="5400000">
+              <a:srgbClr val="000000">
+                <a:alpha val="7000"/>
+              </a:srgbClr>
+            </a:outerShdw>
+          </a:effectLst>
+        </p:spPr>
+      </p:sp>
+      <p:sp>
+        <p:nvSpPr>
+          <p:cNvPr id="37" name="Shape 35"/>
+          <p:cNvSpPr/>
+          <p:nvPr/>
+        </p:nvSpPr>
+        <p:spPr>
+          <a:xfrm>
+            <a:off x="8138160" y="4137660"/>
+            <a:ext cx="3566160" cy="109728"/>
+          </a:xfrm>
+          <a:prstGeom prst="rect">
+            <a:avLst/>
+          </a:prstGeom>
+          <a:solidFill>
+            <a:srgbClr val="00B5E2"/>
+          </a:solidFill>
+          <a:ln w="12700">
+            <a:solidFill>
+              <a:srgbClr val="00B5E2"/>
+            </a:solidFill>
+            <a:prstDash val="solid"/>
+          </a:ln>
+        </p:spPr>
+      </p:sp>
+      <p:sp>
+        <p:nvSpPr>
+          <p:cNvPr id="38" name="Shape 36"/>
+          <p:cNvSpPr/>
+          <p:nvPr/>
+        </p:nvSpPr>
+        <p:spPr>
+          <a:xfrm>
+            <a:off x="8412480" y="4457700"/>
+            <a:ext cx="685800" cy="685800"/>
+          </a:xfrm>
+          <a:prstGeom prst="ellipse">
+            <a:avLst/>
+          </a:prstGeom>
+          <a:solidFill>
+            <a:srgbClr val="004B87"/>
+          </a:solidFill>
+          <a:ln w="12700">
+            <a:solidFill>
+              <a:srgbClr val="004B87"/>
+            </a:solidFill>
+            <a:prstDash val="solid"/>
+          </a:ln>
+        </p:spPr>
+      </p:sp>
+      <p:sp>
+        <p:nvSpPr>
+          <p:cNvPr id="39" name="Text 37"/>
+          <p:cNvSpPr/>
+          <p:nvPr/>
+        </p:nvSpPr>
+        <p:spPr>
+          <a:xfrm>
+            <a:off x="8412480" y="4457700"/>
+            <a:ext cx="685800" cy="685800"/>
+          </a:xfrm>
+          <a:prstGeom prst="rect">
+            <a:avLst/>
+          </a:prstGeom>
+          <a:noFill/>
+          <a:ln/>
+        </p:spPr>
+        <p:txBody>
+          <a:bodyPr wrap="square" lIns="0" tIns="0" rIns="0" bIns="0" rtlCol="0" anchor="ctr"/>
+          <a:lstStyle/>
+          <a:p>
+            <a:pPr algn="ctr" indent="0" marL="0">
+              <a:buNone/>
+            </a:pPr>
+            <a:r>
+              <a:rPr lang="en-US" sz="1400" b="1" dirty="0">
+                <a:solidFill>
+                  <a:srgbClr val="FFFFFF"/>
+                </a:solidFill>
+                <a:latin typeface="Calibri" pitchFamily="34" charset="0"/>
+                <a:ea typeface="Calibri" pitchFamily="34" charset="-122"/>
+                <a:cs typeface="Calibri" pitchFamily="34" charset="-120"/>
+              </a:rPr>
+              <a:t>06</a:t>
+            </a:r>
+            <a:endParaRPr lang="en-US" sz="1400" dirty="0"/>
+          </a:p>
+        </p:txBody>
+      </p:sp>
+      <p:sp>
+        <p:nvSpPr>
+          <p:cNvPr id="40" name="Text 38"/>
+          <p:cNvSpPr/>
+          <p:nvPr/>
+        </p:nvSpPr>
+        <p:spPr>
+          <a:xfrm>
+            <a:off x="9235440" y="4503420"/>
+            <a:ext cx="2331720" cy="594360"/>
+          </a:xfrm>
+          <a:prstGeom prst="rect">
+            <a:avLst/>
+          </a:prstGeom>
+          <a:noFill/>
+          <a:ln/>
+        </p:spPr>
+        <p:txBody>
+          <a:bodyPr wrap="square" lIns="0" tIns="0" rIns="0" bIns="0" rtlCol="0" anchor="ctr"/>
+          <a:lstStyle/>
+          <a:p>
+            <a:pPr indent="0" marL="0">
+              <a:buNone/>
+            </a:pPr>
+            <a:r>
+              <a:rPr lang="en-US" sz="1700" b="1" dirty="0">
+                <a:solidFill>
+                  <a:srgbClr val="001E3C"/>
+                </a:solidFill>
+                <a:latin typeface="Calibri" pitchFamily="34" charset="0"/>
+                <a:ea typeface="Calibri" pitchFamily="34" charset="-122"/>
+                <a:cs typeface="Calibri" pitchFamily="34" charset="-120"/>
+              </a:rPr>
+              <a:t>Safe + configurable</a:t>
+            </a:r>
+            <a:endParaRPr lang="en-US" sz="1700" dirty="0"/>
+          </a:p>
+        </p:txBody>
+      </p:sp>
+      <p:sp>
+        <p:nvSpPr>
+          <p:cNvPr id="41" name="Text 39"/>
+          <p:cNvSpPr/>
+          <p:nvPr/>
+        </p:nvSpPr>
+        <p:spPr>
+          <a:xfrm>
+            <a:off x="8412480" y="5280660"/>
+            <a:ext cx="3017520" cy="525780"/>
+          </a:xfrm>
+          <a:prstGeom prst="rect">
+            <a:avLst/>
+          </a:prstGeom>
+          <a:noFill/>
+          <a:ln/>
+        </p:spPr>
+        <p:txBody>
+          <a:bodyPr wrap="square" rtlCol="0" anchor="ctr"/>
+          <a:lstStyle/>
+          <a:p>
+            <a:pPr indent="0" marL="0">
+              <a:buNone/>
+            </a:pPr>
+            <a:r>
+              <a:rPr lang="en-US" sz="1300" dirty="0">
+                <a:solidFill>
+                  <a:srgbClr val="1E293B"/>
+                </a:solidFill>
+                <a:latin typeface="Calibri" pitchFamily="34" charset="0"/>
+                <a:ea typeface="Calibri" pitchFamily="34" charset="-122"/>
+                <a:cs typeface="Calibri" pitchFamily="34" charset="-120"/>
+              </a:rPr>
+              <a:t>CPE path is untouched. Feature-gated by NVD_KEYWORD_FALLBACK_ENABLED; noise capped by NVD_KEYWORD_RESULTS_LIMIT (default 5).</a:t>
+            </a:r>
+            <a:endParaRPr lang="en-US" sz="1300" dirty="0"/>
+          </a:p>
+        </p:txBody>
+      </p:sp>
+      <p:sp>
+        <p:nvSpPr>
+          <p:cNvPr id="42" name="Shape 40"/>
+          <p:cNvSpPr/>
+          <p:nvPr/>
+        </p:nvSpPr>
+        <p:spPr>
+          <a:xfrm>
+            <a:off x="457200" y="6400800"/>
+            <a:ext cx="11247120" cy="0"/>
+          </a:xfrm>
+          <a:prstGeom prst="line">
+            <a:avLst/>
+          </a:prstGeom>
+          <a:noFill/>
+          <a:ln w="12700">
+            <a:solidFill>
+              <a:srgbClr val="D8E1EC"/>
+            </a:solidFill>
+            <a:prstDash val="solid"/>
+          </a:ln>
+        </p:spPr>
+      </p:sp>
+      <p:sp>
+        <p:nvSpPr>
+          <p:cNvPr id="43" name="Text 41"/>
+          <p:cNvSpPr/>
+          <p:nvPr/>
+        </p:nvSpPr>
+        <p:spPr>
+          <a:xfrm>
+            <a:off x="457200" y="6492240"/>
+            <a:ext cx="7315200" cy="274320"/>
+          </a:xfrm>
+          <a:prstGeom prst="rect">
+            <a:avLst/>
+          </a:prstGeom>
+          <a:noFill/>
+          <a:ln/>
+        </p:spPr>
+        <p:txBody>
+          <a:bodyPr wrap="square" rtlCol="0" anchor="ctr"/>
+          <a:lstStyle/>
+          <a:p>
+            <a:pPr indent="0" marL="0">
+              <a:buNone/>
+            </a:pPr>
+            <a:r>
+              <a:rPr lang="en-US" sz="900" dirty="0">
+                <a:solidFill>
+                  <a:srgbClr val="64748B"/>
+                </a:solidFill>
+                <a:latin typeface="Calibri" pitchFamily="34" charset="0"/>
+                <a:ea typeface="Calibri" pitchFamily="34" charset="-122"/>
+                <a:cs typeface="Calibri" pitchFamily="34" charset="-120"/>
+              </a:rPr>
+              <a:t>SBOM Analyser  |  HCLTech</a:t>
+            </a:r>
+            <a:endParaRPr lang="en-US" sz="900" dirty="0"/>
+          </a:p>
+        </p:txBody>
+      </p:sp>
+      <p:sp>
+        <p:nvSpPr>
+          <p:cNvPr id="44" name="Text 42"/>
+          <p:cNvSpPr/>
+          <p:nvPr/>
+        </p:nvSpPr>
+        <p:spPr>
+          <a:xfrm>
+            <a:off x="10972800" y="6492240"/>
+            <a:ext cx="731520" cy="274320"/>
+          </a:xfrm>
+          <a:prstGeom prst="rect">
+            <a:avLst/>
+          </a:prstGeom>
+          <a:noFill/>
+          <a:ln/>
+        </p:spPr>
+        <p:txBody>
+          <a:bodyPr wrap="square" rtlCol="0" anchor="ctr"/>
+          <a:lstStyle/>
+          <a:p>
+            <a:pPr algn="r" indent="0" marL="0">
+              <a:buNone/>
+            </a:pPr>
+            <a:r>
+              <a:rPr lang="en-US" sz="900" dirty="0">
+                <a:solidFill>
+                  <a:srgbClr val="64748B"/>
+                </a:solidFill>
+                <a:latin typeface="Calibri" pitchFamily="34" charset="0"/>
+                <a:ea typeface="Calibri" pitchFamily="34" charset="-122"/>
+                <a:cs typeface="Calibri" pitchFamily="34" charset="-120"/>
+              </a:rPr>
+              <a:t>9</a:t>
+            </a:r>
+            <a:endParaRPr lang="en-US" sz="900" dirty="0"/>
+          </a:p>
+        </p:txBody>
+      </p:sp>
+    </p:spTree>
+  </p:cSld>
+  <p:clrMapOvr>
+    <a:masterClrMapping/>
+  </p:clrMapOvr>
+</p:sld>
+</file>
+
+<file path=ppt/slides/slide11.xml><?xml version="1.0" encoding="utf-8"?>
+<p:sld xmlns:a="http://schemas.openxmlformats.org/drawingml/2006/main" xmlns:p="http://schemas.openxmlformats.org/presentationml/2006/main" xmlns:r="http://schemas.openxmlformats.org/officeDocument/2006/relationships">
+  <p:cSld>
+    <p:spTree>
+      <p:nvGrpSpPr>
+        <p:cNvPr id="1" name=""/>
+        <p:cNvGrpSpPr/>
+        <p:nvPr/>
+      </p:nvGrpSpPr>
+      <p:grpSpPr/>
+      <p:sp>
+        <p:nvSpPr>
+          <p:cNvPr id="2" name="Shape 0"/>
+          <p:cNvSpPr/>
+          <p:nvPr/>
+        </p:nvSpPr>
+        <p:spPr>
+          <a:xfrm>
+            <a:off x="0" y="0"/>
+            <a:ext cx="12161520" cy="109728"/>
+          </a:xfrm>
+          <a:prstGeom prst="rect">
+            <a:avLst/>
+          </a:prstGeom>
+          <a:solidFill>
+            <a:srgbClr val="00B5E2"/>
+          </a:solidFill>
+          <a:ln w="12700">
+            <a:solidFill>
+              <a:srgbClr val="00B5E2"/>
+            </a:solidFill>
+            <a:prstDash val="solid"/>
+          </a:ln>
+        </p:spPr>
+      </p:sp>
+      <p:sp>
+        <p:nvSpPr>
+          <p:cNvPr id="3" name="Text 1"/>
+          <p:cNvSpPr/>
+          <p:nvPr/>
+        </p:nvSpPr>
+        <p:spPr>
+          <a:xfrm>
+            <a:off x="457200" y="256032"/>
+            <a:ext cx="1828800" cy="457200"/>
+          </a:xfrm>
+          <a:prstGeom prst="rect">
+            <a:avLst/>
+          </a:prstGeom>
+          <a:noFill/>
+          <a:ln/>
+        </p:spPr>
+        <p:txBody>
+          <a:bodyPr wrap="square" lIns="0" tIns="0" rIns="0" bIns="0" rtlCol="0" anchor="ctr"/>
+          <a:lstStyle/>
+          <a:p>
+            <a:pPr indent="0" marL="0">
+              <a:buNone/>
+            </a:pPr>
+            <a:r>
+              <a:rPr lang="en-US" sz="1800" b="1" dirty="0">
+                <a:solidFill>
+                  <a:srgbClr val="004B87"/>
+                </a:solidFill>
+                <a:latin typeface="Calibri" pitchFamily="34" charset="0"/>
+                <a:ea typeface="Calibri" pitchFamily="34" charset="-122"/>
+                <a:cs typeface="Calibri" pitchFamily="34" charset="-120"/>
+              </a:rPr>
+              <a:t>HCL</a:t>
+            </a:r>
+            <a:pPr indent="0" marL="0">
+              <a:buNone/>
+            </a:pPr>
+            <a:r>
+              <a:rPr lang="en-US" sz="1800" b="1" dirty="0">
+                <a:solidFill>
+                  <a:srgbClr val="00B5E2"/>
+                </a:solidFill>
+                <a:latin typeface="Calibri" pitchFamily="34" charset="0"/>
+                <a:ea typeface="Calibri" pitchFamily="34" charset="-122"/>
+                <a:cs typeface="Calibri" pitchFamily="34" charset="-120"/>
+              </a:rPr>
+              <a:t>Tech</a:t>
+            </a:r>
+            <a:endParaRPr lang="en-US" sz="1800" dirty="0"/>
+          </a:p>
+        </p:txBody>
+      </p:sp>
+      <p:sp>
+        <p:nvSpPr>
+          <p:cNvPr id="4" name="Text 2"/>
+          <p:cNvSpPr/>
+          <p:nvPr/>
+        </p:nvSpPr>
+        <p:spPr>
+          <a:xfrm>
+            <a:off x="457200" y="777240"/>
+            <a:ext cx="10972800" cy="274320"/>
+          </a:xfrm>
+          <a:prstGeom prst="rect">
+            <a:avLst/>
+          </a:prstGeom>
+          <a:noFill/>
+          <a:ln/>
+        </p:spPr>
+        <p:txBody>
+          <a:bodyPr wrap="square" lIns="0" tIns="0" rIns="0" bIns="0" rtlCol="0" anchor="ctr"/>
+          <a:lstStyle/>
+          <a:p>
+            <a:pPr indent="0" marL="0">
+              <a:buNone/>
+            </a:pPr>
+            <a:r>
+              <a:rPr lang="en-US" sz="1100" b="1" spc="300" kern="0" dirty="0">
+                <a:solidFill>
+                  <a:srgbClr val="00B5E2"/>
+                </a:solidFill>
+                <a:latin typeface="Calibri" pitchFamily="34" charset="0"/>
+                <a:ea typeface="Calibri" pitchFamily="34" charset="-122"/>
+                <a:cs typeface="Calibri" pitchFamily="34" charset="-120"/>
+              </a:rPr>
+              <a:t>NEXT: ENHANCEMENT ROADMAP</a:t>
+            </a:r>
+            <a:endParaRPr lang="en-US" sz="1100" dirty="0"/>
+          </a:p>
+        </p:txBody>
+      </p:sp>
+      <p:sp>
+        <p:nvSpPr>
+          <p:cNvPr id="5" name="Text 3"/>
+          <p:cNvSpPr/>
+          <p:nvPr/>
+        </p:nvSpPr>
+        <p:spPr>
+          <a:xfrm>
+            <a:off x="457200" y="1051560"/>
+            <a:ext cx="11247120" cy="822960"/>
+          </a:xfrm>
+          <a:prstGeom prst="rect">
+            <a:avLst/>
+          </a:prstGeom>
+          <a:noFill/>
+          <a:ln/>
+        </p:spPr>
+        <p:txBody>
+          <a:bodyPr wrap="square" lIns="0" tIns="0" rIns="0" bIns="0" rtlCol="0" anchor="ctr"/>
+          <a:lstStyle/>
+          <a:p>
+            <a:pPr indent="0" marL="0">
+              <a:buNone/>
+            </a:pPr>
+            <a:r>
+              <a:rPr lang="en-US" sz="3400" b="1" dirty="0">
+                <a:solidFill>
+                  <a:srgbClr val="001E3C"/>
+                </a:solidFill>
+                <a:latin typeface="Calibri" pitchFamily="34" charset="0"/>
+                <a:ea typeface="Calibri" pitchFamily="34" charset="-122"/>
+                <a:cs typeface="Calibri" pitchFamily="34" charset="-120"/>
+              </a:rPr>
+              <a:t>What we ship next</a:t>
+            </a:r>
+            <a:endParaRPr lang="en-US" sz="3400" dirty="0"/>
+          </a:p>
+        </p:txBody>
+      </p:sp>
+      <p:sp>
+        <p:nvSpPr>
+          <p:cNvPr id="6" name="Shape 4"/>
+          <p:cNvSpPr/>
+          <p:nvPr/>
+        </p:nvSpPr>
+        <p:spPr>
+          <a:xfrm>
+            <a:off x="457200" y="2057400"/>
+            <a:ext cx="3566160" cy="1805940"/>
+          </a:xfrm>
+          <a:prstGeom prst="rect">
+            <a:avLst/>
+          </a:prstGeom>
+          <a:solidFill>
+            <a:srgbClr val="FFFFFF"/>
+          </a:solidFill>
+          <a:ln w="12700">
+            <a:solidFill>
+              <a:srgbClr val="D8E1EC"/>
+            </a:solidFill>
+            <a:prstDash val="solid"/>
+          </a:ln>
+          <a:effectLst>
+            <a:outerShdw sx="100000" sy="100000" kx="0" ky="0" algn="bl" rotWithShape="0" blurRad="101600" dist="25400" dir="5400000">
+              <a:srgbClr val="000000">
+                <a:alpha val="7000"/>
+              </a:srgbClr>
+            </a:outerShdw>
+          </a:effectLst>
+        </p:spPr>
+      </p:sp>
+      <p:sp>
+        <p:nvSpPr>
+          <p:cNvPr id="7" name="Shape 5"/>
+          <p:cNvSpPr/>
+          <p:nvPr/>
+        </p:nvSpPr>
+        <p:spPr>
+          <a:xfrm>
+            <a:off x="457200" y="2057400"/>
+            <a:ext cx="3566160" cy="109728"/>
+          </a:xfrm>
+          <a:prstGeom prst="rect">
+            <a:avLst/>
+          </a:prstGeom>
+          <a:solidFill>
+            <a:srgbClr val="00B5E2"/>
+          </a:solidFill>
+          <a:ln w="12700">
+            <a:solidFill>
+              <a:srgbClr val="00B5E2"/>
+            </a:solidFill>
+            <a:prstDash val="solid"/>
+          </a:ln>
+        </p:spPr>
+      </p:sp>
+      <p:sp>
+        <p:nvSpPr>
+          <p:cNvPr id="8" name="Shape 6"/>
+          <p:cNvSpPr/>
+          <p:nvPr/>
+        </p:nvSpPr>
+        <p:spPr>
+          <a:xfrm>
+            <a:off x="731520" y="2377440"/>
+            <a:ext cx="685800" cy="685800"/>
+          </a:xfrm>
+          <a:prstGeom prst="ellipse">
+            <a:avLst/>
+          </a:prstGeom>
+          <a:solidFill>
+            <a:srgbClr val="004B87"/>
+          </a:solidFill>
+          <a:ln w="12700">
+            <a:solidFill>
+              <a:srgbClr val="004B87"/>
+            </a:solidFill>
+            <a:prstDash val="solid"/>
+          </a:ln>
+        </p:spPr>
+      </p:sp>
+      <p:sp>
+        <p:nvSpPr>
+          <p:cNvPr id="9" name="Text 7"/>
+          <p:cNvSpPr/>
+          <p:nvPr/>
+        </p:nvSpPr>
+        <p:spPr>
+          <a:xfrm>
+            <a:off x="731520" y="2377440"/>
+            <a:ext cx="685800" cy="685800"/>
+          </a:xfrm>
+          <a:prstGeom prst="rect">
+            <a:avLst/>
+          </a:prstGeom>
+          <a:noFill/>
+          <a:ln/>
+        </p:spPr>
+        <p:txBody>
+          <a:bodyPr wrap="square" lIns="0" tIns="0" rIns="0" bIns="0" rtlCol="0" anchor="ctr"/>
+          <a:lstStyle/>
+          <a:p>
+            <a:pPr algn="ctr" indent="0" marL="0">
+              <a:buNone/>
+            </a:pPr>
+            <a:r>
+              <a:rPr lang="en-US" sz="1400" b="1" dirty="0">
+                <a:solidFill>
+                  <a:srgbClr val="FFFFFF"/>
+                </a:solidFill>
+                <a:latin typeface="Calibri" pitchFamily="34" charset="0"/>
+                <a:ea typeface="Calibri" pitchFamily="34" charset="-122"/>
+                <a:cs typeface="Calibri" pitchFamily="34" charset="-120"/>
+              </a:rPr>
+              <a:t>01</a:t>
+            </a:r>
+            <a:endParaRPr lang="en-US" sz="1400" dirty="0"/>
+          </a:p>
+        </p:txBody>
+      </p:sp>
+      <p:sp>
+        <p:nvSpPr>
+          <p:cNvPr id="10" name="Text 8"/>
+          <p:cNvSpPr/>
+          <p:nvPr/>
+        </p:nvSpPr>
+        <p:spPr>
+          <a:xfrm>
+            <a:off x="1554480" y="2423160"/>
+            <a:ext cx="2331720" cy="594360"/>
+          </a:xfrm>
+          <a:prstGeom prst="rect">
+            <a:avLst/>
+          </a:prstGeom>
+          <a:noFill/>
+          <a:ln/>
+        </p:spPr>
+        <p:txBody>
+          <a:bodyPr wrap="square" lIns="0" tIns="0" rIns="0" bIns="0" rtlCol="0" anchor="ctr"/>
+          <a:lstStyle/>
+          <a:p>
+            <a:pPr indent="0" marL="0">
+              <a:buNone/>
+            </a:pPr>
+            <a:r>
+              <a:rPr lang="en-US" sz="1700" b="1" dirty="0">
+                <a:solidFill>
+                  <a:srgbClr val="001E3C"/>
+                </a:solidFill>
+                <a:latin typeface="Calibri" pitchFamily="34" charset="0"/>
+                <a:ea typeface="Calibri" pitchFamily="34" charset="-122"/>
+                <a:cs typeface="Calibri" pitchFamily="34" charset="-120"/>
+              </a:rPr>
+              <a:t>Version-range matching</a:t>
+            </a:r>
+            <a:endParaRPr lang="en-US" sz="1700" dirty="0"/>
+          </a:p>
+        </p:txBody>
+      </p:sp>
+      <p:sp>
+        <p:nvSpPr>
+          <p:cNvPr id="11" name="Text 9"/>
+          <p:cNvSpPr/>
+          <p:nvPr/>
+        </p:nvSpPr>
+        <p:spPr>
+          <a:xfrm>
+            <a:off x="731520" y="3200400"/>
+            <a:ext cx="3017520" cy="525780"/>
+          </a:xfrm>
+          <a:prstGeom prst="rect">
+            <a:avLst/>
+          </a:prstGeom>
+          <a:noFill/>
+          <a:ln/>
+        </p:spPr>
+        <p:txBody>
+          <a:bodyPr wrap="square" rtlCol="0" anchor="ctr"/>
+          <a:lstStyle/>
+          <a:p>
+            <a:pPr indent="0" marL="0">
+              <a:buNone/>
+            </a:pPr>
+            <a:r>
+              <a:rPr lang="en-US" sz="1300" dirty="0">
+                <a:solidFill>
+                  <a:srgbClr val="1E293B"/>
+                </a:solidFill>
+                <a:latin typeface="Calibri" pitchFamily="34" charset="0"/>
+                <a:ea typeface="Calibri" pitchFamily="34" charset="-122"/>
+                <a:cs typeface="Calibri" pitchFamily="34" charset="-120"/>
+              </a:rPr>
+              <a:t>Filter NVD findings by affected-version ranges from CPE configurations so patched versions stop showing up as vulnerable.</a:t>
+            </a:r>
+            <a:endParaRPr lang="en-US" sz="1300" dirty="0"/>
+          </a:p>
+        </p:txBody>
+      </p:sp>
+      <p:sp>
+        <p:nvSpPr>
+          <p:cNvPr id="12" name="Shape 10"/>
+          <p:cNvSpPr/>
+          <p:nvPr/>
+        </p:nvSpPr>
+        <p:spPr>
+          <a:xfrm>
+            <a:off x="4297680" y="2057400"/>
+            <a:ext cx="3566160" cy="1805940"/>
+          </a:xfrm>
+          <a:prstGeom prst="rect">
+            <a:avLst/>
+          </a:prstGeom>
+          <a:solidFill>
+            <a:srgbClr val="FFFFFF"/>
+          </a:solidFill>
+          <a:ln w="12700">
+            <a:solidFill>
+              <a:srgbClr val="D8E1EC"/>
+            </a:solidFill>
+            <a:prstDash val="solid"/>
+          </a:ln>
+          <a:effectLst>
+            <a:outerShdw sx="100000" sy="100000" kx="0" ky="0" algn="bl" rotWithShape="0" blurRad="101600" dist="25400" dir="5400000">
+              <a:srgbClr val="000000">
+                <a:alpha val="7000"/>
+              </a:srgbClr>
+            </a:outerShdw>
+          </a:effectLst>
+        </p:spPr>
+      </p:sp>
+      <p:sp>
+        <p:nvSpPr>
+          <p:cNvPr id="13" name="Shape 11"/>
+          <p:cNvSpPr/>
+          <p:nvPr/>
+        </p:nvSpPr>
+        <p:spPr>
+          <a:xfrm>
+            <a:off x="4297680" y="2057400"/>
+            <a:ext cx="3566160" cy="109728"/>
+          </a:xfrm>
+          <a:prstGeom prst="rect">
+            <a:avLst/>
+          </a:prstGeom>
+          <a:solidFill>
+            <a:srgbClr val="00B5E2"/>
+          </a:solidFill>
+          <a:ln w="12700">
+            <a:solidFill>
+              <a:srgbClr val="00B5E2"/>
+            </a:solidFill>
+            <a:prstDash val="solid"/>
+          </a:ln>
+        </p:spPr>
+      </p:sp>
+      <p:sp>
+        <p:nvSpPr>
+          <p:cNvPr id="14" name="Shape 12"/>
+          <p:cNvSpPr/>
+          <p:nvPr/>
+        </p:nvSpPr>
+        <p:spPr>
+          <a:xfrm>
+            <a:off x="4572000" y="2377440"/>
+            <a:ext cx="685800" cy="685800"/>
+          </a:xfrm>
+          <a:prstGeom prst="ellipse">
+            <a:avLst/>
+          </a:prstGeom>
+          <a:solidFill>
+            <a:srgbClr val="004B87"/>
+          </a:solidFill>
+          <a:ln w="12700">
+            <a:solidFill>
+              <a:srgbClr val="004B87"/>
+            </a:solidFill>
+            <a:prstDash val="solid"/>
+          </a:ln>
+        </p:spPr>
+      </p:sp>
+      <p:sp>
+        <p:nvSpPr>
+          <p:cNvPr id="15" name="Text 13"/>
+          <p:cNvSpPr/>
+          <p:nvPr/>
+        </p:nvSpPr>
+        <p:spPr>
+          <a:xfrm>
+            <a:off x="4572000" y="2377440"/>
+            <a:ext cx="685800" cy="685800"/>
+          </a:xfrm>
+          <a:prstGeom prst="rect">
+            <a:avLst/>
+          </a:prstGeom>
+          <a:noFill/>
+          <a:ln/>
+        </p:spPr>
+        <p:txBody>
+          <a:bodyPr wrap="square" lIns="0" tIns="0" rIns="0" bIns="0" rtlCol="0" anchor="ctr"/>
+          <a:lstStyle/>
+          <a:p>
+            <a:pPr algn="ctr" indent="0" marL="0">
+              <a:buNone/>
+            </a:pPr>
+            <a:r>
+              <a:rPr lang="en-US" sz="1400" b="1" dirty="0">
+                <a:solidFill>
+                  <a:srgbClr val="FFFFFF"/>
+                </a:solidFill>
+                <a:latin typeface="Calibri" pitchFamily="34" charset="0"/>
+                <a:ea typeface="Calibri" pitchFamily="34" charset="-122"/>
+                <a:cs typeface="Calibri" pitchFamily="34" charset="-120"/>
+              </a:rPr>
+              <a:t>02</a:t>
+            </a:r>
+            <a:endParaRPr lang="en-US" sz="1400" dirty="0"/>
+          </a:p>
+        </p:txBody>
+      </p:sp>
+      <p:sp>
+        <p:nvSpPr>
+          <p:cNvPr id="16" name="Text 14"/>
+          <p:cNvSpPr/>
+          <p:nvPr/>
+        </p:nvSpPr>
+        <p:spPr>
+          <a:xfrm>
+            <a:off x="5394960" y="2423160"/>
+            <a:ext cx="2331720" cy="594360"/>
+          </a:xfrm>
+          <a:prstGeom prst="rect">
+            <a:avLst/>
+          </a:prstGeom>
+          <a:noFill/>
+          <a:ln/>
+        </p:spPr>
+        <p:txBody>
+          <a:bodyPr wrap="square" lIns="0" tIns="0" rIns="0" bIns="0" rtlCol="0" anchor="ctr"/>
+          <a:lstStyle/>
+          <a:p>
+            <a:pPr indent="0" marL="0">
+              <a:buNone/>
+            </a:pPr>
+            <a:r>
+              <a:rPr lang="en-US" sz="1700" b="1" dirty="0">
+                <a:solidFill>
+                  <a:srgbClr val="001E3C"/>
+                </a:solidFill>
+                <a:latin typeface="Calibri" pitchFamily="34" charset="0"/>
+                <a:ea typeface="Calibri" pitchFamily="34" charset="-122"/>
+                <a:cs typeface="Calibri" pitchFamily="34" charset="-120"/>
+              </a:rPr>
+              <a:t>Response caching</a:t>
+            </a:r>
+            <a:endParaRPr lang="en-US" sz="1700" dirty="0"/>
+          </a:p>
+        </p:txBody>
+      </p:sp>
+      <p:sp>
+        <p:nvSpPr>
+          <p:cNvPr id="17" name="Text 15"/>
+          <p:cNvSpPr/>
+          <p:nvPr/>
+        </p:nvSpPr>
+        <p:spPr>
+          <a:xfrm>
+            <a:off x="4572000" y="3200400"/>
+            <a:ext cx="3017520" cy="525780"/>
+          </a:xfrm>
+          <a:prstGeom prst="rect">
+            <a:avLst/>
+          </a:prstGeom>
+          <a:noFill/>
+          <a:ln/>
+        </p:spPr>
+        <p:txBody>
+          <a:bodyPr wrap="square" rtlCol="0" anchor="ctr"/>
+          <a:lstStyle/>
+          <a:p>
+            <a:pPr indent="0" marL="0">
+              <a:buNone/>
+            </a:pPr>
+            <a:r>
+              <a:rPr lang="en-US" sz="1300" dirty="0">
+                <a:solidFill>
+                  <a:srgbClr val="1E293B"/>
+                </a:solidFill>
+                <a:latin typeface="Calibri" pitchFamily="34" charset="0"/>
+                <a:ea typeface="Calibri" pitchFamily="34" charset="-122"/>
+                <a:cs typeface="Calibri" pitchFamily="34" charset="-120"/>
+              </a:rPr>
+              <a:t>Persist NVD, OSV and GHSA responses with TTL; same SBOM re-scans finish in seconds, not minutes.</a:t>
+            </a:r>
+            <a:endParaRPr lang="en-US" sz="1300" dirty="0"/>
+          </a:p>
+        </p:txBody>
+      </p:sp>
+      <p:sp>
+        <p:nvSpPr>
+          <p:cNvPr id="18" name="Shape 16"/>
+          <p:cNvSpPr/>
+          <p:nvPr/>
+        </p:nvSpPr>
+        <p:spPr>
+          <a:xfrm>
+            <a:off x="8138160" y="2057400"/>
+            <a:ext cx="3566160" cy="1805940"/>
+          </a:xfrm>
+          <a:prstGeom prst="rect">
+            <a:avLst/>
+          </a:prstGeom>
+          <a:solidFill>
+            <a:srgbClr val="FFFFFF"/>
+          </a:solidFill>
+          <a:ln w="12700">
+            <a:solidFill>
+              <a:srgbClr val="D8E1EC"/>
+            </a:solidFill>
+            <a:prstDash val="solid"/>
+          </a:ln>
+          <a:effectLst>
+            <a:outerShdw sx="100000" sy="100000" kx="0" ky="0" algn="bl" rotWithShape="0" blurRad="101600" dist="25400" dir="5400000">
+              <a:srgbClr val="000000">
+                <a:alpha val="7000"/>
+              </a:srgbClr>
+            </a:outerShdw>
+          </a:effectLst>
+        </p:spPr>
+      </p:sp>
+      <p:sp>
+        <p:nvSpPr>
+          <p:cNvPr id="19" name="Shape 17"/>
+          <p:cNvSpPr/>
+          <p:nvPr/>
+        </p:nvSpPr>
+        <p:spPr>
+          <a:xfrm>
+            <a:off x="8138160" y="2057400"/>
+            <a:ext cx="3566160" cy="109728"/>
+          </a:xfrm>
+          <a:prstGeom prst="rect">
+            <a:avLst/>
+          </a:prstGeom>
+          <a:solidFill>
+            <a:srgbClr val="00B5E2"/>
+          </a:solidFill>
+          <a:ln w="12700">
+            <a:solidFill>
+              <a:srgbClr val="00B5E2"/>
+            </a:solidFill>
+            <a:prstDash val="solid"/>
+          </a:ln>
+        </p:spPr>
+      </p:sp>
+      <p:sp>
+        <p:nvSpPr>
+          <p:cNvPr id="20" name="Shape 18"/>
+          <p:cNvSpPr/>
+          <p:nvPr/>
+        </p:nvSpPr>
+        <p:spPr>
+          <a:xfrm>
+            <a:off x="8412480" y="2377440"/>
+            <a:ext cx="685800" cy="685800"/>
+          </a:xfrm>
+          <a:prstGeom prst="ellipse">
+            <a:avLst/>
+          </a:prstGeom>
+          <a:solidFill>
+            <a:srgbClr val="004B87"/>
+          </a:solidFill>
+          <a:ln w="12700">
+            <a:solidFill>
+              <a:srgbClr val="004B87"/>
+            </a:solidFill>
+            <a:prstDash val="solid"/>
+          </a:ln>
+        </p:spPr>
+      </p:sp>
+      <p:sp>
+        <p:nvSpPr>
+          <p:cNvPr id="21" name="Text 19"/>
+          <p:cNvSpPr/>
+          <p:nvPr/>
+        </p:nvSpPr>
+        <p:spPr>
+          <a:xfrm>
+            <a:off x="8412480" y="2377440"/>
+            <a:ext cx="685800" cy="685800"/>
+          </a:xfrm>
+          <a:prstGeom prst="rect">
+            <a:avLst/>
+          </a:prstGeom>
+          <a:noFill/>
+          <a:ln/>
+        </p:spPr>
+        <p:txBody>
+          <a:bodyPr wrap="square" lIns="0" tIns="0" rIns="0" bIns="0" rtlCol="0" anchor="ctr"/>
+          <a:lstStyle/>
+          <a:p>
+            <a:pPr algn="ctr" indent="0" marL="0">
+              <a:buNone/>
+            </a:pPr>
+            <a:r>
+              <a:rPr lang="en-US" sz="1400" b="1" dirty="0">
+                <a:solidFill>
+                  <a:srgbClr val="FFFFFF"/>
+                </a:solidFill>
+                <a:latin typeface="Calibri" pitchFamily="34" charset="0"/>
+                <a:ea typeface="Calibri" pitchFamily="34" charset="-122"/>
+                <a:cs typeface="Calibri" pitchFamily="34" charset="-120"/>
+              </a:rPr>
+              <a:t>03</a:t>
+            </a:r>
+            <a:endParaRPr lang="en-US" sz="1400" dirty="0"/>
+          </a:p>
+        </p:txBody>
+      </p:sp>
+      <p:sp>
+        <p:nvSpPr>
+          <p:cNvPr id="22" name="Text 20"/>
+          <p:cNvSpPr/>
+          <p:nvPr/>
+        </p:nvSpPr>
+        <p:spPr>
+          <a:xfrm>
+            <a:off x="9235440" y="2423160"/>
+            <a:ext cx="2331720" cy="594360"/>
+          </a:xfrm>
+          <a:prstGeom prst="rect">
+            <a:avLst/>
+          </a:prstGeom>
+          <a:noFill/>
+          <a:ln/>
+        </p:spPr>
+        <p:txBody>
+          <a:bodyPr wrap="square" lIns="0" tIns="0" rIns="0" bIns="0" rtlCol="0" anchor="ctr"/>
+          <a:lstStyle/>
+          <a:p>
+            <a:pPr indent="0" marL="0">
+              <a:buNone/>
+            </a:pPr>
+            <a:r>
+              <a:rPr lang="en-US" sz="1700" b="1" dirty="0">
+                <a:solidFill>
+                  <a:srgbClr val="001E3C"/>
+                </a:solidFill>
+                <a:latin typeface="Calibri" pitchFamily="34" charset="0"/>
+                <a:ea typeface="Calibri" pitchFamily="34" charset="-122"/>
+                <a:cs typeface="Calibri" pitchFamily="34" charset="-120"/>
+              </a:rPr>
+              <a:t>Match-confidence score</a:t>
+            </a:r>
+            <a:endParaRPr lang="en-US" sz="1700" dirty="0"/>
+          </a:p>
+        </p:txBody>
+      </p:sp>
+      <p:sp>
+        <p:nvSpPr>
+          <p:cNvPr id="23" name="Text 21"/>
+          <p:cNvSpPr/>
+          <p:nvPr/>
+        </p:nvSpPr>
+        <p:spPr>
+          <a:xfrm>
+            <a:off x="8412480" y="3200400"/>
+            <a:ext cx="3017520" cy="525780"/>
+          </a:xfrm>
+          <a:prstGeom prst="rect">
+            <a:avLst/>
+          </a:prstGeom>
+          <a:noFill/>
+          <a:ln/>
+        </p:spPr>
+        <p:txBody>
+          <a:bodyPr wrap="square" rtlCol="0" anchor="ctr"/>
+          <a:lstStyle/>
+          <a:p>
+            <a:pPr indent="0" marL="0">
+              <a:buNone/>
+            </a:pPr>
+            <a:r>
+              <a:rPr lang="en-US" sz="1300" dirty="0">
+                <a:solidFill>
+                  <a:srgbClr val="1E293B"/>
+                </a:solidFill>
+                <a:latin typeface="Calibri" pitchFamily="34" charset="0"/>
+                <a:ea typeface="Calibri" pitchFamily="34" charset="-122"/>
+                <a:cs typeface="Calibri" pitchFamily="34" charset="-120"/>
+              </a:rPr>
+              <a:t>Rank keyword hits by name + version token strength so analysts can triage high-precision results first.</a:t>
+            </a:r>
+            <a:endParaRPr lang="en-US" sz="1300" dirty="0"/>
+          </a:p>
+        </p:txBody>
+      </p:sp>
+      <p:sp>
+        <p:nvSpPr>
+          <p:cNvPr id="24" name="Shape 22"/>
+          <p:cNvSpPr/>
+          <p:nvPr/>
+        </p:nvSpPr>
+        <p:spPr>
+          <a:xfrm>
+            <a:off x="457200" y="4137660"/>
+            <a:ext cx="3566160" cy="1805940"/>
+          </a:xfrm>
+          <a:prstGeom prst="rect">
+            <a:avLst/>
+          </a:prstGeom>
+          <a:solidFill>
+            <a:srgbClr val="FFFFFF"/>
+          </a:solidFill>
+          <a:ln w="12700">
+            <a:solidFill>
+              <a:srgbClr val="D8E1EC"/>
+            </a:solidFill>
+            <a:prstDash val="solid"/>
+          </a:ln>
+          <a:effectLst>
+            <a:outerShdw sx="100000" sy="100000" kx="0" ky="0" algn="bl" rotWithShape="0" blurRad="101600" dist="25400" dir="5400000">
+              <a:srgbClr val="000000">
+                <a:alpha val="7000"/>
+              </a:srgbClr>
+            </a:outerShdw>
+          </a:effectLst>
+        </p:spPr>
+      </p:sp>
+      <p:sp>
+        <p:nvSpPr>
+          <p:cNvPr id="25" name="Shape 23"/>
+          <p:cNvSpPr/>
+          <p:nvPr/>
+        </p:nvSpPr>
+        <p:spPr>
+          <a:xfrm>
+            <a:off x="457200" y="4137660"/>
+            <a:ext cx="3566160" cy="109728"/>
+          </a:xfrm>
+          <a:prstGeom prst="rect">
+            <a:avLst/>
+          </a:prstGeom>
+          <a:solidFill>
+            <a:srgbClr val="00B5E2"/>
+          </a:solidFill>
+          <a:ln w="12700">
+            <a:solidFill>
+              <a:srgbClr val="00B5E2"/>
+            </a:solidFill>
+            <a:prstDash val="solid"/>
+          </a:ln>
+        </p:spPr>
+      </p:sp>
+      <p:sp>
+        <p:nvSpPr>
+          <p:cNvPr id="26" name="Shape 24"/>
+          <p:cNvSpPr/>
+          <p:nvPr/>
+        </p:nvSpPr>
+        <p:spPr>
+          <a:xfrm>
+            <a:off x="731520" y="4457700"/>
+            <a:ext cx="685800" cy="685800"/>
+          </a:xfrm>
+          <a:prstGeom prst="ellipse">
+            <a:avLst/>
+          </a:prstGeom>
+          <a:solidFill>
+            <a:srgbClr val="004B87"/>
+          </a:solidFill>
+          <a:ln w="12700">
+            <a:solidFill>
+              <a:srgbClr val="004B87"/>
+            </a:solidFill>
+            <a:prstDash val="solid"/>
+          </a:ln>
+        </p:spPr>
+      </p:sp>
+      <p:sp>
+        <p:nvSpPr>
+          <p:cNvPr id="27" name="Text 25"/>
+          <p:cNvSpPr/>
+          <p:nvPr/>
+        </p:nvSpPr>
+        <p:spPr>
+          <a:xfrm>
+            <a:off x="731520" y="4457700"/>
+            <a:ext cx="685800" cy="685800"/>
+          </a:xfrm>
+          <a:prstGeom prst="rect">
+            <a:avLst/>
+          </a:prstGeom>
+          <a:noFill/>
+          <a:ln/>
+        </p:spPr>
+        <p:txBody>
+          <a:bodyPr wrap="square" lIns="0" tIns="0" rIns="0" bIns="0" rtlCol="0" anchor="ctr"/>
+          <a:lstStyle/>
+          <a:p>
+            <a:pPr algn="ctr" indent="0" marL="0">
+              <a:buNone/>
+            </a:pPr>
+            <a:r>
+              <a:rPr lang="en-US" sz="1400" b="1" dirty="0">
+                <a:solidFill>
+                  <a:srgbClr val="FFFFFF"/>
+                </a:solidFill>
+                <a:latin typeface="Calibri" pitchFamily="34" charset="0"/>
+                <a:ea typeface="Calibri" pitchFamily="34" charset="-122"/>
+                <a:cs typeface="Calibri" pitchFamily="34" charset="-120"/>
+              </a:rPr>
+              <a:t>04</a:t>
+            </a:r>
+            <a:endParaRPr lang="en-US" sz="1400" dirty="0"/>
+          </a:p>
+        </p:txBody>
+      </p:sp>
+      <p:sp>
+        <p:nvSpPr>
+          <p:cNvPr id="28" name="Text 26"/>
+          <p:cNvSpPr/>
+          <p:nvPr/>
+        </p:nvSpPr>
+        <p:spPr>
+          <a:xfrm>
+            <a:off x="1554480" y="4503420"/>
+            <a:ext cx="2331720" cy="594360"/>
+          </a:xfrm>
+          <a:prstGeom prst="rect">
+            <a:avLst/>
+          </a:prstGeom>
+          <a:noFill/>
+          <a:ln/>
+        </p:spPr>
+        <p:txBody>
+          <a:bodyPr wrap="square" lIns="0" tIns="0" rIns="0" bIns="0" rtlCol="0" anchor="ctr"/>
+          <a:lstStyle/>
+          <a:p>
+            <a:pPr indent="0" marL="0">
+              <a:buNone/>
+            </a:pPr>
+            <a:r>
+              <a:rPr lang="en-US" sz="1700" b="1" dirty="0">
+                <a:solidFill>
+                  <a:srgbClr val="001E3C"/>
+                </a:solidFill>
+                <a:latin typeface="Calibri" pitchFamily="34" charset="0"/>
+                <a:ea typeface="Calibri" pitchFamily="34" charset="-122"/>
+                <a:cs typeface="Calibri" pitchFamily="34" charset="-120"/>
+              </a:rPr>
+              <a:t>Incremental change feed</a:t>
+            </a:r>
+            <a:endParaRPr lang="en-US" sz="1700" dirty="0"/>
+          </a:p>
+        </p:txBody>
+      </p:sp>
+      <p:sp>
+        <p:nvSpPr>
+          <p:cNvPr id="29" name="Text 27"/>
+          <p:cNvSpPr/>
+          <p:nvPr/>
+        </p:nvSpPr>
+        <p:spPr>
+          <a:xfrm>
+            <a:off x="731520" y="5280660"/>
+            <a:ext cx="3017520" cy="525780"/>
+          </a:xfrm>
+          <a:prstGeom prst="rect">
+            <a:avLst/>
+          </a:prstGeom>
+          <a:noFill/>
+          <a:ln/>
+        </p:spPr>
+        <p:txBody>
+          <a:bodyPr wrap="square" rtlCol="0" anchor="ctr"/>
+          <a:lstStyle/>
+          <a:p>
+            <a:pPr indent="0" marL="0">
+              <a:buNone/>
+            </a:pPr>
+            <a:r>
+              <a:rPr lang="en-US" sz="1300" dirty="0">
+                <a:solidFill>
+                  <a:srgbClr val="1E293B"/>
+                </a:solidFill>
+                <a:latin typeface="Calibri" pitchFamily="34" charset="0"/>
+                <a:ea typeface="Calibri" pitchFamily="34" charset="-122"/>
+                <a:cs typeface="Calibri" pitchFamily="34" charset="-120"/>
+              </a:rPr>
+              <a:t>Use NVD 2.0's pubDate / modDate filters to ingest only new or updated CVEs between runs.</a:t>
+            </a:r>
+            <a:endParaRPr lang="en-US" sz="1300" dirty="0"/>
+          </a:p>
+        </p:txBody>
+      </p:sp>
+      <p:sp>
+        <p:nvSpPr>
+          <p:cNvPr id="30" name="Shape 28"/>
+          <p:cNvSpPr/>
+          <p:nvPr/>
+        </p:nvSpPr>
+        <p:spPr>
+          <a:xfrm>
+            <a:off x="4297680" y="4137660"/>
+            <a:ext cx="3566160" cy="1805940"/>
+          </a:xfrm>
+          <a:prstGeom prst="rect">
+            <a:avLst/>
+          </a:prstGeom>
+          <a:solidFill>
+            <a:srgbClr val="FFFFFF"/>
+          </a:solidFill>
+          <a:ln w="12700">
+            <a:solidFill>
+              <a:srgbClr val="D8E1EC"/>
+            </a:solidFill>
+            <a:prstDash val="solid"/>
+          </a:ln>
+          <a:effectLst>
+            <a:outerShdw sx="100000" sy="100000" kx="0" ky="0" algn="bl" rotWithShape="0" blurRad="101600" dist="25400" dir="5400000">
+              <a:srgbClr val="000000">
+                <a:alpha val="7000"/>
+              </a:srgbClr>
+            </a:outerShdw>
+          </a:effectLst>
+        </p:spPr>
+      </p:sp>
+      <p:sp>
+        <p:nvSpPr>
+          <p:cNvPr id="31" name="Shape 29"/>
+          <p:cNvSpPr/>
+          <p:nvPr/>
+        </p:nvSpPr>
+        <p:spPr>
+          <a:xfrm>
+            <a:off x="4297680" y="4137660"/>
+            <a:ext cx="3566160" cy="109728"/>
+          </a:xfrm>
+          <a:prstGeom prst="rect">
+            <a:avLst/>
+          </a:prstGeom>
+          <a:solidFill>
+            <a:srgbClr val="00B5E2"/>
+          </a:solidFill>
+          <a:ln w="12700">
+            <a:solidFill>
+              <a:srgbClr val="00B5E2"/>
+            </a:solidFill>
+            <a:prstDash val="solid"/>
+          </a:ln>
+        </p:spPr>
+      </p:sp>
+      <p:sp>
+        <p:nvSpPr>
+          <p:cNvPr id="32" name="Shape 30"/>
+          <p:cNvSpPr/>
+          <p:nvPr/>
+        </p:nvSpPr>
+        <p:spPr>
+          <a:xfrm>
+            <a:off x="4572000" y="4457700"/>
+            <a:ext cx="685800" cy="685800"/>
+          </a:xfrm>
+          <a:prstGeom prst="ellipse">
+            <a:avLst/>
+          </a:prstGeom>
+          <a:solidFill>
+            <a:srgbClr val="004B87"/>
+          </a:solidFill>
+          <a:ln w="12700">
+            <a:solidFill>
+              <a:srgbClr val="004B87"/>
+            </a:solidFill>
+            <a:prstDash val="solid"/>
+          </a:ln>
+        </p:spPr>
+      </p:sp>
+      <p:sp>
+        <p:nvSpPr>
+          <p:cNvPr id="33" name="Text 31"/>
+          <p:cNvSpPr/>
+          <p:nvPr/>
+        </p:nvSpPr>
+        <p:spPr>
+          <a:xfrm>
+            <a:off x="4572000" y="4457700"/>
+            <a:ext cx="685800" cy="685800"/>
+          </a:xfrm>
+          <a:prstGeom prst="rect">
+            <a:avLst/>
+          </a:prstGeom>
+          <a:noFill/>
+          <a:ln/>
+        </p:spPr>
+        <p:txBody>
+          <a:bodyPr wrap="square" lIns="0" tIns="0" rIns="0" bIns="0" rtlCol="0" anchor="ctr"/>
+          <a:lstStyle/>
+          <a:p>
+            <a:pPr algn="ctr" indent="0" marL="0">
+              <a:buNone/>
+            </a:pPr>
+            <a:r>
+              <a:rPr lang="en-US" sz="1400" b="1" dirty="0">
+                <a:solidFill>
+                  <a:srgbClr val="FFFFFF"/>
+                </a:solidFill>
+                <a:latin typeface="Calibri" pitchFamily="34" charset="0"/>
+                <a:ea typeface="Calibri" pitchFamily="34" charset="-122"/>
+                <a:cs typeface="Calibri" pitchFamily="34" charset="-120"/>
+              </a:rPr>
+              <a:t>05</a:t>
+            </a:r>
+            <a:endParaRPr lang="en-US" sz="1400" dirty="0"/>
+          </a:p>
+        </p:txBody>
+      </p:sp>
+      <p:sp>
+        <p:nvSpPr>
+          <p:cNvPr id="34" name="Text 32"/>
+          <p:cNvSpPr/>
+          <p:nvPr/>
+        </p:nvSpPr>
+        <p:spPr>
+          <a:xfrm>
+            <a:off x="5394960" y="4503420"/>
+            <a:ext cx="2331720" cy="594360"/>
+          </a:xfrm>
+          <a:prstGeom prst="rect">
+            <a:avLst/>
+          </a:prstGeom>
+          <a:noFill/>
+          <a:ln/>
+        </p:spPr>
+        <p:txBody>
+          <a:bodyPr wrap="square" lIns="0" tIns="0" rIns="0" bIns="0" rtlCol="0" anchor="ctr"/>
+          <a:lstStyle/>
+          <a:p>
+            <a:pPr indent="0" marL="0">
+              <a:buNone/>
+            </a:pPr>
+            <a:r>
+              <a:rPr lang="en-US" sz="1700" b="1" dirty="0">
+                <a:solidFill>
+                  <a:srgbClr val="001E3C"/>
+                </a:solidFill>
+                <a:latin typeface="Calibri" pitchFamily="34" charset="0"/>
+                <a:ea typeface="Calibri" pitchFamily="34" charset="-122"/>
+                <a:cs typeface="Calibri" pitchFamily="34" charset="-120"/>
+              </a:rPr>
+              <a:t>Broader PURL → CPE coverage</a:t>
+            </a:r>
+            <a:endParaRPr lang="en-US" sz="1700" dirty="0"/>
+          </a:p>
+        </p:txBody>
+      </p:sp>
+      <p:sp>
+        <p:nvSpPr>
+          <p:cNvPr id="35" name="Text 33"/>
+          <p:cNvSpPr/>
+          <p:nvPr/>
+        </p:nvSpPr>
+        <p:spPr>
+          <a:xfrm>
+            <a:off x="4572000" y="5280660"/>
+            <a:ext cx="3017520" cy="525780"/>
+          </a:xfrm>
+          <a:prstGeom prst="rect">
+            <a:avLst/>
+          </a:prstGeom>
+          <a:noFill/>
+          <a:ln/>
+        </p:spPr>
+        <p:txBody>
+          <a:bodyPr wrap="square" rtlCol="0" anchor="ctr"/>
+          <a:lstStyle/>
+          <a:p>
+            <a:pPr indent="0" marL="0">
+              <a:buNone/>
+            </a:pPr>
+            <a:r>
+              <a:rPr lang="en-US" sz="1300" dirty="0">
+                <a:solidFill>
+                  <a:srgbClr val="1E293B"/>
+                </a:solidFill>
+                <a:latin typeface="Calibri" pitchFamily="34" charset="0"/>
+                <a:ea typeface="Calibri" pitchFamily="34" charset="-122"/>
+                <a:cs typeface="Calibri" pitchFamily="34" charset="-120"/>
+              </a:rPr>
+              <a:t>Add resolvers for Alpine, Debian, RPM and Conan ecosystems so fewer components need the keyword fallback.</a:t>
+            </a:r>
+            <a:endParaRPr lang="en-US" sz="1300" dirty="0"/>
+          </a:p>
+        </p:txBody>
+      </p:sp>
+      <p:sp>
+        <p:nvSpPr>
+          <p:cNvPr id="36" name="Shape 34"/>
+          <p:cNvSpPr/>
+          <p:nvPr/>
+        </p:nvSpPr>
+        <p:spPr>
+          <a:xfrm>
+            <a:off x="8138160" y="4137660"/>
+            <a:ext cx="3566160" cy="1805940"/>
+          </a:xfrm>
+          <a:prstGeom prst="rect">
+            <a:avLst/>
+          </a:prstGeom>
+          <a:solidFill>
+            <a:srgbClr val="FFFFFF"/>
+          </a:solidFill>
+          <a:ln w="12700">
+            <a:solidFill>
+              <a:srgbClr val="D8E1EC"/>
+            </a:solidFill>
+            <a:prstDash val="solid"/>
+          </a:ln>
+          <a:effectLst>
+            <a:outerShdw sx="100000" sy="100000" kx="0" ky="0" algn="bl" rotWithShape="0" blurRad="101600" dist="25400" dir="5400000">
+              <a:srgbClr val="000000">
+                <a:alpha val="7000"/>
+              </a:srgbClr>
+            </a:outerShdw>
+          </a:effectLst>
+        </p:spPr>
+      </p:sp>
+      <p:sp>
+        <p:nvSpPr>
+          <p:cNvPr id="37" name="Shape 35"/>
+          <p:cNvSpPr/>
+          <p:nvPr/>
+        </p:nvSpPr>
+        <p:spPr>
+          <a:xfrm>
+            <a:off x="8138160" y="4137660"/>
+            <a:ext cx="3566160" cy="109728"/>
+          </a:xfrm>
+          <a:prstGeom prst="rect">
+            <a:avLst/>
+          </a:prstGeom>
+          <a:solidFill>
+            <a:srgbClr val="00B5E2"/>
+          </a:solidFill>
+          <a:ln w="12700">
+            <a:solidFill>
+              <a:srgbClr val="00B5E2"/>
+            </a:solidFill>
+            <a:prstDash val="solid"/>
+          </a:ln>
+        </p:spPr>
+      </p:sp>
+      <p:sp>
+        <p:nvSpPr>
+          <p:cNvPr id="38" name="Shape 36"/>
+          <p:cNvSpPr/>
+          <p:nvPr/>
+        </p:nvSpPr>
+        <p:spPr>
+          <a:xfrm>
+            <a:off x="8412480" y="4457700"/>
+            <a:ext cx="685800" cy="685800"/>
+          </a:xfrm>
+          <a:prstGeom prst="ellipse">
+            <a:avLst/>
+          </a:prstGeom>
+          <a:solidFill>
+            <a:srgbClr val="004B87"/>
+          </a:solidFill>
+          <a:ln w="12700">
+            <a:solidFill>
+              <a:srgbClr val="004B87"/>
+            </a:solidFill>
+            <a:prstDash val="solid"/>
+          </a:ln>
+        </p:spPr>
+      </p:sp>
+      <p:sp>
+        <p:nvSpPr>
+          <p:cNvPr id="39" name="Text 37"/>
+          <p:cNvSpPr/>
+          <p:nvPr/>
+        </p:nvSpPr>
+        <p:spPr>
+          <a:xfrm>
+            <a:off x="8412480" y="4457700"/>
+            <a:ext cx="685800" cy="685800"/>
+          </a:xfrm>
+          <a:prstGeom prst="rect">
+            <a:avLst/>
+          </a:prstGeom>
+          <a:noFill/>
+          <a:ln/>
+        </p:spPr>
+        <p:txBody>
+          <a:bodyPr wrap="square" lIns="0" tIns="0" rIns="0" bIns="0" rtlCol="0" anchor="ctr"/>
+          <a:lstStyle/>
+          <a:p>
+            <a:pPr algn="ctr" indent="0" marL="0">
+              <a:buNone/>
+            </a:pPr>
+            <a:r>
+              <a:rPr lang="en-US" sz="1400" b="1" dirty="0">
+                <a:solidFill>
+                  <a:srgbClr val="FFFFFF"/>
+                </a:solidFill>
+                <a:latin typeface="Calibri" pitchFamily="34" charset="0"/>
+                <a:ea typeface="Calibri" pitchFamily="34" charset="-122"/>
+                <a:cs typeface="Calibri" pitchFamily="34" charset="-120"/>
+              </a:rPr>
+              <a:t>06</a:t>
+            </a:r>
+            <a:endParaRPr lang="en-US" sz="1400" dirty="0"/>
+          </a:p>
+        </p:txBody>
+      </p:sp>
+      <p:sp>
+        <p:nvSpPr>
+          <p:cNvPr id="40" name="Text 38"/>
+          <p:cNvSpPr/>
+          <p:nvPr/>
+        </p:nvSpPr>
+        <p:spPr>
+          <a:xfrm>
+            <a:off x="9235440" y="4503420"/>
+            <a:ext cx="2331720" cy="594360"/>
+          </a:xfrm>
+          <a:prstGeom prst="rect">
+            <a:avLst/>
+          </a:prstGeom>
+          <a:noFill/>
+          <a:ln/>
+        </p:spPr>
+        <p:txBody>
+          <a:bodyPr wrap="square" lIns="0" tIns="0" rIns="0" bIns="0" rtlCol="0" anchor="ctr"/>
+          <a:lstStyle/>
+          <a:p>
+            <a:pPr indent="0" marL="0">
+              <a:buNone/>
+            </a:pPr>
+            <a:r>
+              <a:rPr lang="en-US" sz="1700" b="1" dirty="0">
+                <a:solidFill>
+                  <a:srgbClr val="001E3C"/>
+                </a:solidFill>
+                <a:latin typeface="Calibri" pitchFamily="34" charset="0"/>
+                <a:ea typeface="Calibri" pitchFamily="34" charset="-122"/>
+                <a:cs typeface="Calibri" pitchFamily="34" charset="-120"/>
+              </a:rPr>
+              <a:t>Match-reason telemetry</a:t>
+            </a:r>
+            <a:endParaRPr lang="en-US" sz="1700" dirty="0"/>
+          </a:p>
+        </p:txBody>
+      </p:sp>
+      <p:sp>
+        <p:nvSpPr>
+          <p:cNvPr id="41" name="Text 39"/>
+          <p:cNvSpPr/>
+          <p:nvPr/>
+        </p:nvSpPr>
+        <p:spPr>
+          <a:xfrm>
+            <a:off x="8412480" y="5280660"/>
+            <a:ext cx="3017520" cy="525780"/>
+          </a:xfrm>
+          <a:prstGeom prst="rect">
+            <a:avLst/>
+          </a:prstGeom>
+          <a:noFill/>
+          <a:ln/>
+        </p:spPr>
+        <p:txBody>
+          <a:bodyPr wrap="square" rtlCol="0" anchor="ctr"/>
+          <a:lstStyle/>
+          <a:p>
+            <a:pPr indent="0" marL="0">
+              <a:buNone/>
+            </a:pPr>
+            <a:r>
+              <a:rPr lang="en-US" sz="1300" dirty="0">
+                <a:solidFill>
+                  <a:srgbClr val="1E293B"/>
+                </a:solidFill>
+                <a:latin typeface="Calibri" pitchFamily="34" charset="0"/>
+                <a:ea typeface="Calibri" pitchFamily="34" charset="-122"/>
+                <a:cs typeface="Calibri" pitchFamily="34" charset="-120"/>
+              </a:rPr>
+              <a:t>Record per-finding whether it came from cpeName, virtualMatchString or keywordSearch — surfaced in exports and UI.</a:t>
+            </a:r>
+            <a:endParaRPr lang="en-US" sz="1300" dirty="0"/>
+          </a:p>
+        </p:txBody>
+      </p:sp>
+      <p:sp>
+        <p:nvSpPr>
+          <p:cNvPr id="42" name="Shape 40"/>
+          <p:cNvSpPr/>
+          <p:nvPr/>
+        </p:nvSpPr>
+        <p:spPr>
+          <a:xfrm>
+            <a:off x="457200" y="6400800"/>
+            <a:ext cx="11247120" cy="0"/>
+          </a:xfrm>
+          <a:prstGeom prst="line">
+            <a:avLst/>
+          </a:prstGeom>
+          <a:noFill/>
+          <a:ln w="12700">
+            <a:solidFill>
+              <a:srgbClr val="D8E1EC"/>
+            </a:solidFill>
+            <a:prstDash val="solid"/>
+          </a:ln>
+        </p:spPr>
+      </p:sp>
+      <p:sp>
+        <p:nvSpPr>
+          <p:cNvPr id="43" name="Text 41"/>
+          <p:cNvSpPr/>
+          <p:nvPr/>
+        </p:nvSpPr>
+        <p:spPr>
+          <a:xfrm>
+            <a:off x="457200" y="6492240"/>
+            <a:ext cx="7315200" cy="274320"/>
+          </a:xfrm>
+          <a:prstGeom prst="rect">
+            <a:avLst/>
+          </a:prstGeom>
+          <a:noFill/>
+          <a:ln/>
+        </p:spPr>
+        <p:txBody>
+          <a:bodyPr wrap="square" rtlCol="0" anchor="ctr"/>
+          <a:lstStyle/>
+          <a:p>
+            <a:pPr indent="0" marL="0">
+              <a:buNone/>
+            </a:pPr>
+            <a:r>
+              <a:rPr lang="en-US" sz="900" dirty="0">
+                <a:solidFill>
+                  <a:srgbClr val="64748B"/>
+                </a:solidFill>
+                <a:latin typeface="Calibri" pitchFamily="34" charset="0"/>
+                <a:ea typeface="Calibri" pitchFamily="34" charset="-122"/>
+                <a:cs typeface="Calibri" pitchFamily="34" charset="-120"/>
+              </a:rPr>
+              <a:t>SBOM Analyser  |  HCLTech</a:t>
+            </a:r>
+            <a:endParaRPr lang="en-US" sz="900" dirty="0"/>
+          </a:p>
+        </p:txBody>
+      </p:sp>
+      <p:sp>
+        <p:nvSpPr>
+          <p:cNvPr id="44" name="Text 42"/>
+          <p:cNvSpPr/>
+          <p:nvPr/>
+        </p:nvSpPr>
+        <p:spPr>
+          <a:xfrm>
+            <a:off x="10972800" y="6492240"/>
+            <a:ext cx="731520" cy="274320"/>
+          </a:xfrm>
+          <a:prstGeom prst="rect">
+            <a:avLst/>
+          </a:prstGeom>
+          <a:noFill/>
+          <a:ln/>
+        </p:spPr>
+        <p:txBody>
+          <a:bodyPr wrap="square" rtlCol="0" anchor="ctr"/>
+          <a:lstStyle/>
+          <a:p>
+            <a:pPr algn="r" indent="0" marL="0">
+              <a:buNone/>
+            </a:pPr>
+            <a:r>
+              <a:rPr lang="en-US" sz="900" dirty="0">
+                <a:solidFill>
+                  <a:srgbClr val="64748B"/>
+                </a:solidFill>
+                <a:latin typeface="Calibri" pitchFamily="34" charset="0"/>
+                <a:ea typeface="Calibri" pitchFamily="34" charset="-122"/>
+                <a:cs typeface="Calibri" pitchFamily="34" charset="-120"/>
+              </a:rPr>
+              <a:t>10</a:t>
+            </a:r>
+            <a:endParaRPr lang="en-US" sz="900" dirty="0"/>
           </a:p>
         </p:txBody>
       </p:sp>

</xml_diff>